<commit_message>
feat(report): update migration slide with current progress
- Flights 254/254 (100%), Hotels 119/133 (89%), Transportation 22/148 (15%)
- Overall migration 53% (397/753)
- Add blocked tests note (24 tests, supplier errors/known bugs)
- Add passing rate description to Daily Stability Run
- Add migration trend chart (Sprint 9: 45%, Sprint 10: 53%)
- Update composition to match CI (Flights 205, Hotels 111, Transportation 24)
- Remove 'Why Playwright' section and 'Executive snapshot' subtitle
</commit_message>
<xml_diff>
--- a/docs/Test-Migration-Progress.pptx
+++ b/docs/Test-Migration-Progress.pptx
@@ -105,6 +105,268 @@
     </a:lvl9pPr>
   </p:defaultTextStyle>
 </p:presentation>
+</file>
+
+<file path=ppt/charts/chart1.xml><?xml version="1.0" encoding="utf-8"?>
+<c:chartSpace xmlns:c="http://schemas.openxmlformats.org/drawingml/2006/chart" xmlns:a="http://schemas.openxmlformats.org/drawingml/2006/main" xmlns:r="http://schemas.openxmlformats.org/officeDocument/2006/relationships">
+  <c:date1904 val="0"/>
+  <c:roundedCorners val="1"/>
+  <c:chart>
+    <c:autoTitleDeleted val="1"/>
+    <c:plotArea>
+      <c:layout/>
+      <c:lineChart>
+        <c:varyColors val="0"/>
+        <c:ser>
+          <c:idx val="0"/>
+          <c:order val="0"/>
+          <c:tx>
+            <c:strRef>
+              <c:f>Sheet1!$B$1</c:f>
+              <c:strCache>
+                <c:ptCount val="1"/>
+                <c:pt idx="0">
+                  <c:v>Migration %</c:v>
+                </c:pt>
+              </c:strCache>
+            </c:strRef>
+          </c:tx>
+          <c:spPr>
+            <a:solidFill>
+              <a:srgbClr val="10B981"/>
+            </a:solidFill>
+            <a:ln w="25400" cap="flat">
+              <a:solidFill>
+                <a:srgbClr val="10B981"/>
+              </a:solidFill>
+              <a:prstDash val="solid"/>
+              <a:round/>
+            </a:ln>
+            <a:effectLst/>
+          </c:spPr>
+          <c:invertIfNegative val="0"/>
+          <c:dLbls>
+            <c:numFmt formatCode="0&quot;%&quot;" sourceLinked="0"/>
+            <c:txPr>
+              <a:bodyPr/>
+              <a:lstStyle/>
+              <a:p>
+                <a:pPr>
+                  <a:defRPr b="0" i="0" strike="noStrike" sz="1000" u="none">
+                    <a:solidFill>
+                      <a:srgbClr val="1F2937"/>
+                    </a:solidFill>
+                    <a:latin typeface="Arial"/>
+                  </a:defRPr>
+                </a:pPr>
+              </a:p>
+            </c:txPr>
+            <c:showLegendKey val="0"/>
+            <c:showVal val="1"/>
+            <c:showCatName val="0"/>
+            <c:showSerName val="0"/>
+            <c:showPercent val="0"/>
+            <c:showBubbleSize val="0"/>
+            <c:showLeaderLines val="0"/>
+          </c:dLbls>
+          <c:marker>
+            <c:symbol val="circle"/>
+            <c:size val="8"/>
+            <c:spPr>
+              <a:solidFill>
+                <a:srgbClr val="10B981"/>
+              </a:solidFill>
+              <a:ln w="9525" cap="flat">
+                <a:solidFill>
+                  <a:srgbClr val="10B981"/>
+                </a:solidFill>
+                <a:prstDash val="solid"/>
+                <a:round/>
+              </a:ln>
+              <a:effectLst/>
+            </c:spPr>
+          </c:marker>
+          <c:cat>
+            <c:multiLvlStrRef>
+              <c:f>Sheet1!$A$2:$A$3</c:f>
+              <c:multiLvlStrCache>
+                <c:ptCount val="2"/>
+                <c:lvl>
+                  <c:pt idx="0">
+                    <c:v>Sprint 9</c:v>
+                  </c:pt>
+                  <c:pt idx="1">
+                    <c:v>Sprint 10</c:v>
+                  </c:pt>
+                </c:lvl>
+              </c:multiLvlStrCache>
+            </c:multiLvlStrRef>
+          </c:cat>
+          <c:val>
+            <c:numRef>
+              <c:f>Sheet1!$B$2:$B$3</c:f>
+              <c:numCache>
+                <c:formatCode>General</c:formatCode>
+                <c:ptCount val="2"/>
+                <c:pt idx="0">
+                  <c:v>45</c:v>
+                </c:pt>
+                <c:pt idx="1">
+                  <c:v>53</c:v>
+                </c:pt>
+              </c:numCache>
+            </c:numRef>
+          </c:val>
+          <c:smooth val="0"/>
+        </c:ser>
+        <c:dLbls>
+          <c:numFmt formatCode="0&quot;%&quot;" sourceLinked="0"/>
+          <c:txPr>
+            <a:bodyPr/>
+            <a:lstStyle/>
+            <a:p>
+              <a:pPr>
+                <a:defRPr b="0" i="0" strike="noStrike" sz="1000" u="none">
+                  <a:solidFill>
+                    <a:srgbClr val="1F2937"/>
+                  </a:solidFill>
+                  <a:latin typeface="Arial"/>
+                </a:defRPr>
+              </a:pPr>
+            </a:p>
+          </c:txPr>
+          <c:showLegendKey val="0"/>
+          <c:showVal val="1"/>
+          <c:showCatName val="0"/>
+          <c:showSerName val="0"/>
+          <c:showPercent val="0"/>
+          <c:showBubbleSize val="0"/>
+          <c:showLeaderLines val="0"/>
+        </c:dLbls>
+        <c:marker val="1"/>
+        <c:axId val="2094734554"/>
+        <c:axId val="2094734552"/>
+        <c:axId val="2094734556"/>
+      </c:lineChart>
+      <c:catAx>
+        <c:axId val="2094734554"/>
+        <c:scaling>
+          <c:orientation val="minMax"/>
+        </c:scaling>
+        <c:delete val="0"/>
+        <c:axPos val="b"/>
+        <c:numFmt formatCode="General" sourceLinked="1"/>
+        <c:majorTickMark val="out"/>
+        <c:minorTickMark val="none"/>
+        <c:tickLblPos val="low"/>
+        <c:spPr>
+          <a:ln w="12700" cap="flat">
+            <a:solidFill>
+              <a:srgbClr val="888888"/>
+            </a:solidFill>
+            <a:prstDash val="solid"/>
+            <a:round/>
+          </a:ln>
+        </c:spPr>
+        <c:txPr>
+          <a:bodyPr/>
+          <a:lstStyle/>
+          <a:p>
+            <a:pPr>
+              <a:defRPr sz="1000" b="0" i="0" u="none" strike="noStrike">
+                <a:solidFill>
+                  <a:srgbClr val="1F2937"/>
+                </a:solidFill>
+                <a:latin typeface="Arial"/>
+              </a:defRPr>
+            </a:pPr>
+            <a:endParaRPr lang="en-US"/>
+          </a:p>
+        </c:txPr>
+        <c:crossAx val="2094734552"/>
+        <c:crosses val="autoZero"/>
+        <c:auto val="1"/>
+        <c:lblAlgn val="ctr"/>
+        <c:noMultiLvlLbl val="1"/>
+      </c:catAx>
+      <c:valAx>
+        <c:axId val="2094734552"/>
+        <c:scaling>
+          <c:orientation val="minMax"/>
+          <c:max val="100"/>
+          <c:min val="0"/>
+        </c:scaling>
+        <c:delete val="0"/>
+        <c:axPos val="l"/>
+        <c:majorGridlines>
+          <c:spPr>
+            <a:ln w="12700" cap="flat">
+              <a:solidFill>
+                <a:srgbClr val="888888"/>
+              </a:solidFill>
+              <a:prstDash val="solid"/>
+              <a:round/>
+            </a:ln>
+          </c:spPr>
+        </c:majorGridlines>
+        <c:numFmt formatCode="0&quot;%&quot;" sourceLinked="0"/>
+        <c:majorTickMark val="out"/>
+        <c:minorTickMark val="none"/>
+        <c:tickLblPos val="nextTo"/>
+        <c:spPr>
+          <a:ln w="12700" cap="flat">
+            <a:solidFill>
+              <a:srgbClr val="888888"/>
+            </a:solidFill>
+            <a:prstDash val="solid"/>
+            <a:round/>
+          </a:ln>
+        </c:spPr>
+        <c:txPr>
+          <a:bodyPr/>
+          <a:lstStyle/>
+          <a:p>
+            <a:pPr>
+              <a:defRPr sz="900" b="0" i="0" u="none" strike="noStrike">
+                <a:solidFill>
+                  <a:srgbClr val="6B7280"/>
+                </a:solidFill>
+                <a:latin typeface="Arial"/>
+              </a:defRPr>
+            </a:pPr>
+            <a:endParaRPr lang="en-US"/>
+          </a:p>
+        </c:txPr>
+        <c:crossAx val="2094734554"/>
+        <c:crosses val="autoZero"/>
+        <c:crossBetween val="between"/>
+      </c:valAx>
+      <c:spPr>
+        <a:solidFill>
+          <a:srgbClr val="FFFFFF"/>
+        </a:solidFill>
+        <a:ln w="12700" cap="flat">
+          <a:solidFill>
+            <a:srgbClr val="E5E7EB"/>
+          </a:solidFill>
+        </a:ln>
+        <a:effectLst/>
+      </c:spPr>
+    </c:plotArea>
+    <c:plotVisOnly val="1"/>
+    <c:dispBlanksAs val="span"/>
+  </c:chart>
+  <c:spPr>
+    <a:noFill/>
+    <a:ln>
+      <a:noFill/>
+    </a:ln>
+    <a:effectLst/>
+  </c:spPr>
+  <c:externalData r:id="rId1">
+    <c:autoUpdate val="0"/>
+  </c:externalData>
+</c:chartSpace>
 </file>
 
 <file path=ppt/notesMasters/notesMaster1.xml><?xml version="1.0" encoding="utf-8"?>
@@ -947,7 +1209,7 @@
                 <a:ea typeface="Calibri" pitchFamily="34" charset="-122"/>
                 <a:cs typeface="Calibri" pitchFamily="34" charset="-120"/>
               </a:rPr>
-              <a:t>Scope: OBT tests only  •  Executive snapshot</a:t>
+              <a:t>Scope: OBT tests only</a:t>
             </a:r>
             <a:endParaRPr lang="en-US" sz="1200" dirty="0"/>
           </a:p>
@@ -1009,7 +1271,7 @@
                 <a:ea typeface="Calibri" pitchFamily="34" charset="-122"/>
                 <a:cs typeface="Calibri" pitchFamily="34" charset="-120"/>
               </a:rPr>
-              <a:t>Why Playwright</a:t>
+              <a:t>AI Agents accelerating migration</a:t>
             </a:r>
             <a:endParaRPr lang="en-US" sz="1400" dirty="0"/>
           </a:p>
@@ -1024,173 +1286,7 @@
         <p:spPr>
           <a:xfrm>
             <a:off x="365760" y="1581912"/>
-            <a:ext cx="3840480" cy="1463040"/>
-          </a:xfrm>
-          <a:prstGeom prst="rect">
-            <a:avLst/>
-          </a:prstGeom>
-          <a:noFill/>
-          <a:ln/>
-        </p:spPr>
-        <p:txBody>
-          <a:bodyPr wrap="square" rtlCol="0" anchor="ctr"/>
-          <a:lstStyle/>
-          <a:p>
-            <a:pPr marL="342900" indent="-342900">
-              <a:spcAft>
-                <a:spcPts val="400"/>
-              </a:spcAft>
-              <a:buSzPct val="100000"/>
-              <a:buChar char="■"/>
-            </a:pPr>
-            <a:r>
-              <a:rPr lang="en-US" sz="1100" dirty="0">
-                <a:solidFill>
-                  <a:srgbClr val="1F2937"/>
-                </a:solidFill>
-                <a:latin typeface="Calibri" pitchFamily="34" charset="0"/>
-                <a:ea typeface="Calibri" pitchFamily="34" charset="-122"/>
-                <a:cs typeface="Calibri" pitchFamily="34" charset="-120"/>
-              </a:rPr>
-              <a:t>Full control over selectors &amp; waits</a:t>
-            </a:r>
-            <a:endParaRPr lang="en-US" sz="1100" dirty="0"/>
-          </a:p>
-          <a:p>
-            <a:pPr marL="342900" indent="-342900">
-              <a:spcAft>
-                <a:spcPts val="400"/>
-              </a:spcAft>
-              <a:buSzPct val="100000"/>
-              <a:buChar char="■"/>
-            </a:pPr>
-            <a:r>
-              <a:rPr lang="en-US" sz="1100" dirty="0">
-                <a:solidFill>
-                  <a:srgbClr val="1F2937"/>
-                </a:solidFill>
-                <a:latin typeface="Calibri" pitchFamily="34" charset="0"/>
-                <a:ea typeface="Calibri" pitchFamily="34" charset="-122"/>
-                <a:cs typeface="Calibri" pitchFamily="34" charset="-120"/>
-              </a:rPr>
-              <a:t>Deterministic behavior</a:t>
-            </a:r>
-            <a:endParaRPr lang="en-US" sz="1100" dirty="0"/>
-          </a:p>
-          <a:p>
-            <a:pPr marL="342900" indent="-342900">
-              <a:spcAft>
-                <a:spcPts val="400"/>
-              </a:spcAft>
-              <a:buSzPct val="100000"/>
-              <a:buChar char="■"/>
-            </a:pPr>
-            <a:r>
-              <a:rPr lang="en-US" sz="1100" dirty="0">
-                <a:solidFill>
-                  <a:srgbClr val="1F2937"/>
-                </a:solidFill>
-                <a:latin typeface="Calibri" pitchFamily="34" charset="0"/>
-                <a:ea typeface="Calibri" pitchFamily="34" charset="-122"/>
-                <a:cs typeface="Calibri" pitchFamily="34" charset="-120"/>
-              </a:rPr>
-              <a:t>Better debugging (logs, traces, screenshots)</a:t>
-            </a:r>
-            <a:endParaRPr lang="en-US" sz="1100" dirty="0"/>
-          </a:p>
-          <a:p>
-            <a:pPr marL="342900" indent="-342900">
-              <a:spcAft>
-                <a:spcPts val="400"/>
-              </a:spcAft>
-              <a:buSzPct val="100000"/>
-              <a:buChar char="■"/>
-            </a:pPr>
-            <a:r>
-              <a:rPr lang="en-US" sz="1100" dirty="0">
-                <a:solidFill>
-                  <a:srgbClr val="1F2937"/>
-                </a:solidFill>
-                <a:latin typeface="Calibri" pitchFamily="34" charset="0"/>
-                <a:ea typeface="Calibri" pitchFamily="34" charset="-122"/>
-                <a:cs typeface="Calibri" pitchFamily="34" charset="-120"/>
-              </a:rPr>
-              <a:t>Clean architecture (DSL + POM)</a:t>
-            </a:r>
-            <a:endParaRPr lang="en-US" sz="1100" dirty="0"/>
-          </a:p>
-          <a:p>
-            <a:pPr marL="342900" indent="-342900">
-              <a:spcAft>
-                <a:spcPts val="400"/>
-              </a:spcAft>
-              <a:buSzPct val="100000"/>
-              <a:buChar char="■"/>
-            </a:pPr>
-            <a:r>
-              <a:rPr lang="en-US" sz="1100" dirty="0">
-                <a:solidFill>
-                  <a:srgbClr val="1F2937"/>
-                </a:solidFill>
-                <a:latin typeface="Calibri" pitchFamily="34" charset="0"/>
-                <a:ea typeface="Calibri" pitchFamily="34" charset="-122"/>
-                <a:cs typeface="Calibri" pitchFamily="34" charset="-120"/>
-              </a:rPr>
-              <a:t>Strong CI/CD + Git workflows</a:t>
-            </a:r>
-            <a:endParaRPr lang="en-US" sz="1100" dirty="0"/>
-          </a:p>
-        </p:txBody>
-      </p:sp>
-      <p:sp>
-        <p:nvSpPr>
-          <p:cNvPr id="7" name="Text 5"/>
-          <p:cNvSpPr/>
-          <p:nvPr/>
-        </p:nvSpPr>
-        <p:spPr>
-          <a:xfrm>
-            <a:off x="365760" y="3136392"/>
-            <a:ext cx="3840480" cy="320040"/>
-          </a:xfrm>
-          <a:prstGeom prst="rect">
-            <a:avLst/>
-          </a:prstGeom>
-          <a:noFill/>
-          <a:ln/>
-        </p:spPr>
-        <p:txBody>
-          <a:bodyPr wrap="square" rtlCol="0" anchor="ctr"/>
-          <a:lstStyle/>
-          <a:p>
-            <a:pPr indent="0" marL="0">
-              <a:buNone/>
-            </a:pPr>
-            <a:r>
-              <a:rPr lang="en-US" sz="1400" b="1" dirty="0">
-                <a:solidFill>
-                  <a:srgbClr val="2563EB"/>
-                </a:solidFill>
-                <a:latin typeface="Calibri" pitchFamily="34" charset="0"/>
-                <a:ea typeface="Calibri" pitchFamily="34" charset="-122"/>
-                <a:cs typeface="Calibri" pitchFamily="34" charset="-120"/>
-              </a:rPr>
-              <a:t>AI Agents accelerating migration</a:t>
-            </a:r>
-            <a:endParaRPr lang="en-US" sz="1400" dirty="0"/>
-          </a:p>
-        </p:txBody>
-      </p:sp>
-      <p:sp>
-        <p:nvSpPr>
-          <p:cNvPr id="8" name="Text 6"/>
-          <p:cNvSpPr/>
-          <p:nvPr/>
-        </p:nvSpPr>
-        <p:spPr>
-          <a:xfrm>
-            <a:off x="365760" y="3483864"/>
-            <a:ext cx="3840480" cy="1463040"/>
+            <a:ext cx="3840480" cy="1280160"/>
           </a:xfrm>
           <a:prstGeom prst="rect">
             <a:avLst/>
@@ -1347,7 +1443,62 @@
       </p:sp>
       <p:sp>
         <p:nvSpPr>
-          <p:cNvPr id="9" name="Shape 7"/>
+          <p:cNvPr id="7" name="Text 5"/>
+          <p:cNvSpPr/>
+          <p:nvPr/>
+        </p:nvSpPr>
+        <p:spPr>
+          <a:xfrm>
+            <a:off x="365760" y="2953512"/>
+            <a:ext cx="3840480" cy="274320"/>
+          </a:xfrm>
+          <a:prstGeom prst="rect">
+            <a:avLst/>
+          </a:prstGeom>
+          <a:noFill/>
+          <a:ln/>
+        </p:spPr>
+        <p:txBody>
+          <a:bodyPr wrap="square" rtlCol="0" anchor="ctr"/>
+          <a:lstStyle/>
+          <a:p>
+            <a:pPr indent="0" marL="0">
+              <a:buNone/>
+            </a:pPr>
+            <a:r>
+              <a:rPr lang="en-US" sz="1200" b="1" dirty="0">
+                <a:solidFill>
+                  <a:srgbClr val="2563EB"/>
+                </a:solidFill>
+                <a:latin typeface="Calibri" pitchFamily="34" charset="0"/>
+                <a:ea typeface="Calibri" pitchFamily="34" charset="-122"/>
+                <a:cs typeface="Calibri" pitchFamily="34" charset="-120"/>
+              </a:rPr>
+              <a:t>Migration Progress per Sprint</a:t>
+            </a:r>
+            <a:endParaRPr lang="en-US" sz="1200" dirty="0"/>
+          </a:p>
+        </p:txBody>
+      </p:sp>
+      <p:graphicFrame>
+        <p:nvGraphicFramePr>
+          <p:cNvPr id="8" name="Chart 0" descr=""/>
+          <p:cNvGraphicFramePr/>
+          <p:nvPr/>
+        </p:nvGraphicFramePr>
+        <p:xfrm>
+          <a:off x="365760" y="3227832"/>
+          <a:ext cx="3840480" cy="2011680"/>
+        </p:xfrm>
+        <a:graphic xmlns:a="http://schemas.openxmlformats.org/drawingml/2006/main">
+          <a:graphicData uri="http://schemas.openxmlformats.org/drawingml/2006/chart">
+            <c:chart xmlns:c="http://schemas.openxmlformats.org/drawingml/2006/chart" r:id="rId1"/>
+          </a:graphicData>
+        </a:graphic>
+      </p:graphicFrame>
+      <p:sp>
+        <p:nvSpPr>
+          <p:cNvPr id="9" name="Shape 6"/>
           <p:cNvSpPr/>
           <p:nvPr/>
         </p:nvSpPr>
@@ -1374,7 +1525,7 @@
       </p:sp>
       <p:sp>
         <p:nvSpPr>
-          <p:cNvPr id="10" name="Text 8"/>
+          <p:cNvPr id="10" name="Text 7"/>
           <p:cNvSpPr/>
           <p:nvPr/>
         </p:nvSpPr>
@@ -1413,7 +1564,7 @@
       </p:sp>
       <p:sp>
         <p:nvSpPr>
-          <p:cNvPr id="11" name="Text 9"/>
+          <p:cNvPr id="11" name="Text 8"/>
           <p:cNvSpPr/>
           <p:nvPr/>
         </p:nvSpPr>
@@ -1444,7 +1595,7 @@
                 <a:ea typeface="Calibri" pitchFamily="34" charset="-122"/>
                 <a:cs typeface="Calibri" pitchFamily="34" charset="-120"/>
               </a:rPr>
-              <a:t>40%</a:t>
+              <a:t>53%</a:t>
             </a:r>
             <a:endParaRPr lang="en-US" sz="6400" dirty="0"/>
           </a:p>
@@ -1452,7 +1603,7 @@
       </p:sp>
       <p:sp>
         <p:nvSpPr>
-          <p:cNvPr id="12" name="Text 10"/>
+          <p:cNvPr id="12" name="Text 9"/>
           <p:cNvSpPr/>
           <p:nvPr/>
         </p:nvSpPr>
@@ -1483,7 +1634,7 @@
                 <a:ea typeface="Calibri" pitchFamily="34" charset="-122"/>
                 <a:cs typeface="Calibri" pitchFamily="34" charset="-120"/>
               </a:rPr>
-              <a:t>296 / 740 tests migrated</a:t>
+              <a:t>397 / 753 tests migrated</a:t>
             </a:r>
             <a:endParaRPr lang="en-US" sz="1300" dirty="0"/>
           </a:p>
@@ -1491,13 +1642,13 @@
       </p:sp>
       <p:sp>
         <p:nvSpPr>
-          <p:cNvPr id="13" name="Text 11"/>
-          <p:cNvSpPr/>
-          <p:nvPr/>
-        </p:nvSpPr>
-        <p:spPr>
-          <a:xfrm>
-            <a:off x="4434840" y="2926080"/>
+          <p:cNvPr id="13" name="Text 10"/>
+          <p:cNvSpPr/>
+          <p:nvPr/>
+        </p:nvSpPr>
+        <p:spPr>
+          <a:xfrm>
+            <a:off x="4434840" y="2834640"/>
             <a:ext cx="3383280" cy="320040"/>
           </a:xfrm>
           <a:prstGeom prst="rect">
@@ -1530,13 +1681,13 @@
       </p:sp>
       <p:sp>
         <p:nvSpPr>
-          <p:cNvPr id="14" name="Text 12"/>
-          <p:cNvSpPr/>
-          <p:nvPr/>
-        </p:nvSpPr>
-        <p:spPr>
-          <a:xfrm>
-            <a:off x="4434840" y="3291840"/>
+          <p:cNvPr id="14" name="Text 11"/>
+          <p:cNvSpPr/>
+          <p:nvPr/>
+        </p:nvSpPr>
+        <p:spPr>
+          <a:xfrm>
+            <a:off x="4434840" y="3200400"/>
             <a:ext cx="1280160" cy="228600"/>
           </a:xfrm>
           <a:prstGeom prst="rect">
@@ -1569,13 +1720,13 @@
       </p:sp>
       <p:sp>
         <p:nvSpPr>
-          <p:cNvPr id="15" name="Text 13"/>
-          <p:cNvSpPr/>
-          <p:nvPr/>
-        </p:nvSpPr>
-        <p:spPr>
-          <a:xfrm>
-            <a:off x="5715000" y="3291840"/>
+          <p:cNvPr id="15" name="Text 12"/>
+          <p:cNvSpPr/>
+          <p:nvPr/>
+        </p:nvSpPr>
+        <p:spPr>
+          <a:xfrm>
+            <a:off x="5715000" y="3200400"/>
             <a:ext cx="914400" cy="228600"/>
           </a:xfrm>
           <a:prstGeom prst="rect">
@@ -1600,7 +1751,7 @@
                 <a:ea typeface="Calibri" pitchFamily="34" charset="-122"/>
                 <a:cs typeface="Calibri" pitchFamily="34" charset="-120"/>
               </a:rPr>
-              <a:t>119/119</a:t>
+              <a:t>119/133</a:t>
             </a:r>
             <a:endParaRPr lang="en-US" sz="1000" dirty="0"/>
           </a:p>
@@ -1608,13 +1759,13 @@
       </p:sp>
       <p:sp>
         <p:nvSpPr>
-          <p:cNvPr id="16" name="Text 14"/>
-          <p:cNvSpPr/>
-          <p:nvPr/>
-        </p:nvSpPr>
-        <p:spPr>
-          <a:xfrm>
-            <a:off x="7269480" y="3291840"/>
+          <p:cNvPr id="16" name="Text 13"/>
+          <p:cNvSpPr/>
+          <p:nvPr/>
+        </p:nvSpPr>
+        <p:spPr>
+          <a:xfrm>
+            <a:off x="7269480" y="3200400"/>
             <a:ext cx="548640" cy="228600"/>
           </a:xfrm>
           <a:prstGeom prst="rect">
@@ -1639,7 +1790,7 @@
                 <a:ea typeface="Calibri" pitchFamily="34" charset="-122"/>
                 <a:cs typeface="Calibri" pitchFamily="34" charset="-120"/>
               </a:rPr>
-              <a:t>100%</a:t>
+              <a:t>89%</a:t>
             </a:r>
             <a:endParaRPr lang="en-US" sz="1100" dirty="0"/>
           </a:p>
@@ -1647,18 +1798,18 @@
       </p:sp>
       <p:sp>
         <p:nvSpPr>
-          <p:cNvPr id="17" name="Shape 15"/>
-          <p:cNvSpPr/>
-          <p:nvPr/>
-        </p:nvSpPr>
-        <p:spPr>
-          <a:xfrm>
-            <a:off x="4434840" y="3538728"/>
-            <a:ext cx="3383280" cy="201168"/>
+          <p:cNvPr id="17" name="Shape 14"/>
+          <p:cNvSpPr/>
+          <p:nvPr/>
+        </p:nvSpPr>
+        <p:spPr>
+          <a:xfrm>
+            <a:off x="4434840" y="3447288"/>
+            <a:ext cx="3383280" cy="182880"/>
           </a:xfrm>
           <a:prstGeom prst="roundRect">
             <a:avLst>
-              <a:gd name="adj" fmla="val 22727"/>
+              <a:gd name="adj" fmla="val 25000"/>
             </a:avLst>
           </a:prstGeom>
           <a:solidFill>
@@ -1674,18 +1825,18 @@
       </p:sp>
       <p:sp>
         <p:nvSpPr>
-          <p:cNvPr id="18" name="Shape 16"/>
-          <p:cNvSpPr/>
-          <p:nvPr/>
-        </p:nvSpPr>
-        <p:spPr>
-          <a:xfrm>
-            <a:off x="4434840" y="3538728"/>
-            <a:ext cx="3383280" cy="201168"/>
+          <p:cNvPr id="18" name="Shape 15"/>
+          <p:cNvSpPr/>
+          <p:nvPr/>
+        </p:nvSpPr>
+        <p:spPr>
+          <a:xfrm>
+            <a:off x="4434840" y="3447288"/>
+            <a:ext cx="3011119" cy="182880"/>
           </a:xfrm>
           <a:prstGeom prst="roundRect">
             <a:avLst>
-              <a:gd name="adj" fmla="val 22727"/>
+              <a:gd name="adj" fmla="val 25000"/>
             </a:avLst>
           </a:prstGeom>
           <a:solidFill>
@@ -1701,13 +1852,13 @@
       </p:sp>
       <p:sp>
         <p:nvSpPr>
-          <p:cNvPr id="19" name="Text 17"/>
-          <p:cNvSpPr/>
-          <p:nvPr/>
-        </p:nvSpPr>
-        <p:spPr>
-          <a:xfrm>
-            <a:off x="4434840" y="3794760"/>
+          <p:cNvPr id="19" name="Text 16"/>
+          <p:cNvSpPr/>
+          <p:nvPr/>
+        </p:nvSpPr>
+        <p:spPr>
+          <a:xfrm>
+            <a:off x="4434840" y="3675888"/>
             <a:ext cx="1280160" cy="228600"/>
           </a:xfrm>
           <a:prstGeom prst="rect">
@@ -1740,13 +1891,13 @@
       </p:sp>
       <p:sp>
         <p:nvSpPr>
-          <p:cNvPr id="20" name="Text 18"/>
-          <p:cNvSpPr/>
-          <p:nvPr/>
-        </p:nvSpPr>
-        <p:spPr>
-          <a:xfrm>
-            <a:off x="5715000" y="3794760"/>
+          <p:cNvPr id="20" name="Text 17"/>
+          <p:cNvSpPr/>
+          <p:nvPr/>
+        </p:nvSpPr>
+        <p:spPr>
+          <a:xfrm>
+            <a:off x="5715000" y="3675888"/>
             <a:ext cx="914400" cy="228600"/>
           </a:xfrm>
           <a:prstGeom prst="rect">
@@ -1771,7 +1922,7 @@
                 <a:ea typeface="Calibri" pitchFamily="34" charset="-122"/>
                 <a:cs typeface="Calibri" pitchFamily="34" charset="-120"/>
               </a:rPr>
-              <a:t>166/255</a:t>
+              <a:t>254/254</a:t>
             </a:r>
             <a:endParaRPr lang="en-US" sz="1000" dirty="0"/>
           </a:p>
@@ -1779,13 +1930,13 @@
       </p:sp>
       <p:sp>
         <p:nvSpPr>
-          <p:cNvPr id="21" name="Text 19"/>
-          <p:cNvSpPr/>
-          <p:nvPr/>
-        </p:nvSpPr>
-        <p:spPr>
-          <a:xfrm>
-            <a:off x="7269480" y="3794760"/>
+          <p:cNvPr id="21" name="Text 18"/>
+          <p:cNvSpPr/>
+          <p:nvPr/>
+        </p:nvSpPr>
+        <p:spPr>
+          <a:xfrm>
+            <a:off x="7269480" y="3675888"/>
             <a:ext cx="548640" cy="228600"/>
           </a:xfrm>
           <a:prstGeom prst="rect">
@@ -1810,7 +1961,7 @@
                 <a:ea typeface="Calibri" pitchFamily="34" charset="-122"/>
                 <a:cs typeface="Calibri" pitchFamily="34" charset="-120"/>
               </a:rPr>
-              <a:t>65%</a:t>
+              <a:t>100%</a:t>
             </a:r>
             <a:endParaRPr lang="en-US" sz="1100" dirty="0"/>
           </a:p>
@@ -1818,18 +1969,18 @@
       </p:sp>
       <p:sp>
         <p:nvSpPr>
-          <p:cNvPr id="22" name="Shape 20"/>
-          <p:cNvSpPr/>
-          <p:nvPr/>
-        </p:nvSpPr>
-        <p:spPr>
-          <a:xfrm>
-            <a:off x="4434840" y="4041648"/>
-            <a:ext cx="3383280" cy="201168"/>
+          <p:cNvPr id="22" name="Shape 19"/>
+          <p:cNvSpPr/>
+          <p:nvPr/>
+        </p:nvSpPr>
+        <p:spPr>
+          <a:xfrm>
+            <a:off x="4434840" y="3922776"/>
+            <a:ext cx="3383280" cy="182880"/>
           </a:xfrm>
           <a:prstGeom prst="roundRect">
             <a:avLst>
-              <a:gd name="adj" fmla="val 22727"/>
+              <a:gd name="adj" fmla="val 25000"/>
             </a:avLst>
           </a:prstGeom>
           <a:solidFill>
@@ -1845,18 +1996,18 @@
       </p:sp>
       <p:sp>
         <p:nvSpPr>
-          <p:cNvPr id="23" name="Shape 21"/>
-          <p:cNvSpPr/>
-          <p:nvPr/>
-        </p:nvSpPr>
-        <p:spPr>
-          <a:xfrm>
-            <a:off x="4434840" y="4041648"/>
-            <a:ext cx="2199132" cy="201168"/>
+          <p:cNvPr id="23" name="Shape 20"/>
+          <p:cNvSpPr/>
+          <p:nvPr/>
+        </p:nvSpPr>
+        <p:spPr>
+          <a:xfrm>
+            <a:off x="4434840" y="3922776"/>
+            <a:ext cx="3383280" cy="182880"/>
           </a:xfrm>
           <a:prstGeom prst="roundRect">
             <a:avLst>
-              <a:gd name="adj" fmla="val 22727"/>
+              <a:gd name="adj" fmla="val 25000"/>
             </a:avLst>
           </a:prstGeom>
           <a:solidFill>
@@ -1872,13 +2023,13 @@
       </p:sp>
       <p:sp>
         <p:nvSpPr>
-          <p:cNvPr id="24" name="Text 22"/>
-          <p:cNvSpPr/>
-          <p:nvPr/>
-        </p:nvSpPr>
-        <p:spPr>
-          <a:xfrm>
-            <a:off x="4434840" y="4297680"/>
+          <p:cNvPr id="24" name="Text 21"/>
+          <p:cNvSpPr/>
+          <p:nvPr/>
+        </p:nvSpPr>
+        <p:spPr>
+          <a:xfrm>
+            <a:off x="4434840" y="4151376"/>
             <a:ext cx="1280160" cy="228600"/>
           </a:xfrm>
           <a:prstGeom prst="rect">
@@ -1911,13 +2062,13 @@
       </p:sp>
       <p:sp>
         <p:nvSpPr>
-          <p:cNvPr id="25" name="Text 23"/>
-          <p:cNvSpPr/>
-          <p:nvPr/>
-        </p:nvSpPr>
-        <p:spPr>
-          <a:xfrm>
-            <a:off x="5715000" y="4297680"/>
+          <p:cNvPr id="25" name="Text 22"/>
+          <p:cNvSpPr/>
+          <p:nvPr/>
+        </p:nvSpPr>
+        <p:spPr>
+          <a:xfrm>
+            <a:off x="5715000" y="4151376"/>
             <a:ext cx="914400" cy="228600"/>
           </a:xfrm>
           <a:prstGeom prst="rect">
@@ -1942,7 +2093,7 @@
                 <a:ea typeface="Calibri" pitchFamily="34" charset="-122"/>
                 <a:cs typeface="Calibri" pitchFamily="34" charset="-120"/>
               </a:rPr>
-              <a:t>9/148</a:t>
+              <a:t>22/148</a:t>
             </a:r>
             <a:endParaRPr lang="en-US" sz="1000" dirty="0"/>
           </a:p>
@@ -1950,13 +2101,13 @@
       </p:sp>
       <p:sp>
         <p:nvSpPr>
-          <p:cNvPr id="26" name="Text 24"/>
-          <p:cNvSpPr/>
-          <p:nvPr/>
-        </p:nvSpPr>
-        <p:spPr>
-          <a:xfrm>
-            <a:off x="7269480" y="4297680"/>
+          <p:cNvPr id="26" name="Text 23"/>
+          <p:cNvSpPr/>
+          <p:nvPr/>
+        </p:nvSpPr>
+        <p:spPr>
+          <a:xfrm>
+            <a:off x="7269480" y="4151376"/>
             <a:ext cx="548640" cy="228600"/>
           </a:xfrm>
           <a:prstGeom prst="rect">
@@ -1981,7 +2132,7 @@
                 <a:ea typeface="Calibri" pitchFamily="34" charset="-122"/>
                 <a:cs typeface="Calibri" pitchFamily="34" charset="-120"/>
               </a:rPr>
-              <a:t>6%</a:t>
+              <a:t>15%</a:t>
             </a:r>
             <a:endParaRPr lang="en-US" sz="1100" dirty="0"/>
           </a:p>
@@ -1989,18 +2140,18 @@
       </p:sp>
       <p:sp>
         <p:nvSpPr>
-          <p:cNvPr id="27" name="Shape 25"/>
-          <p:cNvSpPr/>
-          <p:nvPr/>
-        </p:nvSpPr>
-        <p:spPr>
-          <a:xfrm>
-            <a:off x="4434840" y="4544568"/>
-            <a:ext cx="3383280" cy="201168"/>
+          <p:cNvPr id="27" name="Shape 24"/>
+          <p:cNvSpPr/>
+          <p:nvPr/>
+        </p:nvSpPr>
+        <p:spPr>
+          <a:xfrm>
+            <a:off x="4434840" y="4398264"/>
+            <a:ext cx="3383280" cy="182880"/>
           </a:xfrm>
           <a:prstGeom prst="roundRect">
             <a:avLst>
-              <a:gd name="adj" fmla="val 22727"/>
+              <a:gd name="adj" fmla="val 25000"/>
             </a:avLst>
           </a:prstGeom>
           <a:solidFill>
@@ -2016,18 +2167,18 @@
       </p:sp>
       <p:sp>
         <p:nvSpPr>
-          <p:cNvPr id="28" name="Shape 26"/>
-          <p:cNvSpPr/>
-          <p:nvPr/>
-        </p:nvSpPr>
-        <p:spPr>
-          <a:xfrm>
-            <a:off x="4434840" y="4544568"/>
-            <a:ext cx="202997" cy="201168"/>
+          <p:cNvPr id="28" name="Shape 25"/>
+          <p:cNvSpPr/>
+          <p:nvPr/>
+        </p:nvSpPr>
+        <p:spPr>
+          <a:xfrm>
+            <a:off x="4434840" y="4398264"/>
+            <a:ext cx="507492" cy="182880"/>
           </a:xfrm>
           <a:prstGeom prst="roundRect">
             <a:avLst>
-              <a:gd name="adj" fmla="val 22727"/>
+              <a:gd name="adj" fmla="val 25000"/>
             </a:avLst>
           </a:prstGeom>
           <a:solidFill>
@@ -2043,13 +2194,13 @@
       </p:sp>
       <p:sp>
         <p:nvSpPr>
-          <p:cNvPr id="29" name="Text 27"/>
-          <p:cNvSpPr/>
-          <p:nvPr/>
-        </p:nvSpPr>
-        <p:spPr>
-          <a:xfrm>
-            <a:off x="4434840" y="4800600"/>
+          <p:cNvPr id="29" name="Text 26"/>
+          <p:cNvSpPr/>
+          <p:nvPr/>
+        </p:nvSpPr>
+        <p:spPr>
+          <a:xfrm>
+            <a:off x="4434840" y="4626864"/>
             <a:ext cx="1280160" cy="228600"/>
           </a:xfrm>
           <a:prstGeom prst="rect">
@@ -2082,13 +2233,13 @@
       </p:sp>
       <p:sp>
         <p:nvSpPr>
-          <p:cNvPr id="30" name="Text 28"/>
-          <p:cNvSpPr/>
-          <p:nvPr/>
-        </p:nvSpPr>
-        <p:spPr>
-          <a:xfrm>
-            <a:off x="5715000" y="4800600"/>
+          <p:cNvPr id="30" name="Text 27"/>
+          <p:cNvSpPr/>
+          <p:nvPr/>
+        </p:nvSpPr>
+        <p:spPr>
+          <a:xfrm>
+            <a:off x="5715000" y="4626864"/>
             <a:ext cx="914400" cy="228600"/>
           </a:xfrm>
           <a:prstGeom prst="rect">
@@ -2121,13 +2272,13 @@
       </p:sp>
       <p:sp>
         <p:nvSpPr>
-          <p:cNvPr id="31" name="Text 29"/>
-          <p:cNvSpPr/>
-          <p:nvPr/>
-        </p:nvSpPr>
-        <p:spPr>
-          <a:xfrm>
-            <a:off x="7269480" y="4800600"/>
+          <p:cNvPr id="31" name="Text 28"/>
+          <p:cNvSpPr/>
+          <p:nvPr/>
+        </p:nvSpPr>
+        <p:spPr>
+          <a:xfrm>
+            <a:off x="7269480" y="4626864"/>
             <a:ext cx="548640" cy="228600"/>
           </a:xfrm>
           <a:prstGeom prst="rect">
@@ -2160,18 +2311,18 @@
       </p:sp>
       <p:sp>
         <p:nvSpPr>
-          <p:cNvPr id="32" name="Shape 30"/>
-          <p:cNvSpPr/>
-          <p:nvPr/>
-        </p:nvSpPr>
-        <p:spPr>
-          <a:xfrm>
-            <a:off x="4434840" y="5047488"/>
-            <a:ext cx="3383280" cy="201168"/>
+          <p:cNvPr id="32" name="Shape 29"/>
+          <p:cNvSpPr/>
+          <p:nvPr/>
+        </p:nvSpPr>
+        <p:spPr>
+          <a:xfrm>
+            <a:off x="4434840" y="4873752"/>
+            <a:ext cx="3383280" cy="182880"/>
           </a:xfrm>
           <a:prstGeom prst="roundRect">
             <a:avLst>
-              <a:gd name="adj" fmla="val 22727"/>
+              <a:gd name="adj" fmla="val 25000"/>
             </a:avLst>
           </a:prstGeom>
           <a:solidFill>
@@ -2187,14 +2338,14 @@
       </p:sp>
       <p:sp>
         <p:nvSpPr>
-          <p:cNvPr id="33" name="Shape 31"/>
-          <p:cNvSpPr/>
-          <p:nvPr/>
-        </p:nvSpPr>
-        <p:spPr>
-          <a:xfrm>
-            <a:off x="4434840" y="5047488"/>
-            <a:ext cx="45720" cy="201168"/>
+          <p:cNvPr id="33" name="Shape 30"/>
+          <p:cNvSpPr/>
+          <p:nvPr/>
+        </p:nvSpPr>
+        <p:spPr>
+          <a:xfrm>
+            <a:off x="4434840" y="4873752"/>
+            <a:ext cx="45720" cy="182880"/>
           </a:xfrm>
           <a:prstGeom prst="roundRect">
             <a:avLst>
@@ -2214,13 +2365,52 @@
       </p:sp>
       <p:sp>
         <p:nvSpPr>
-          <p:cNvPr id="34" name="Shape 32"/>
-          <p:cNvSpPr/>
-          <p:nvPr/>
-        </p:nvSpPr>
-        <p:spPr>
-          <a:xfrm>
-            <a:off x="4434840" y="5394960"/>
+          <p:cNvPr id="34" name="Text 31"/>
+          <p:cNvSpPr/>
+          <p:nvPr/>
+        </p:nvSpPr>
+        <p:spPr>
+          <a:xfrm>
+            <a:off x="4434840" y="5193792"/>
+            <a:ext cx="3383280" cy="320040"/>
+          </a:xfrm>
+          <a:prstGeom prst="rect">
+            <a:avLst/>
+          </a:prstGeom>
+          <a:noFill/>
+          <a:ln/>
+        </p:spPr>
+        <p:txBody>
+          <a:bodyPr wrap="square" rtlCol="0" anchor="ctr"/>
+          <a:lstStyle/>
+          <a:p>
+            <a:pPr indent="0" marL="0">
+              <a:buNone/>
+            </a:pPr>
+            <a:r>
+              <a:rPr lang="en-US" sz="900" i="1" dirty="0">
+                <a:solidFill>
+                  <a:srgbClr val="F59E0B"/>
+                </a:solidFill>
+                <a:latin typeface="Calibri" pitchFamily="34" charset="0"/>
+                <a:ea typeface="Calibri" pitchFamily="34" charset="-122"/>
+                <a:cs typeface="Calibri" pitchFamily="34" charset="-120"/>
+              </a:rPr>
+              <a:t>🚧 24 tests blocked (supplier errors / known bugs) – pending review</a:t>
+            </a:r>
+            <a:endParaRPr lang="en-US" sz="900" dirty="0"/>
+          </a:p>
+        </p:txBody>
+      </p:sp>
+      <p:sp>
+        <p:nvSpPr>
+          <p:cNvPr id="35" name="Shape 32"/>
+          <p:cNvSpPr/>
+          <p:nvPr/>
+        </p:nvSpPr>
+        <p:spPr>
+          <a:xfrm>
+            <a:off x="4434840" y="5559552"/>
             <a:ext cx="164592" cy="164592"/>
           </a:xfrm>
           <a:prstGeom prst="rect">
@@ -2239,13 +2429,13 @@
       </p:sp>
       <p:sp>
         <p:nvSpPr>
-          <p:cNvPr id="35" name="Text 33"/>
-          <p:cNvSpPr/>
-          <p:nvPr/>
-        </p:nvSpPr>
-        <p:spPr>
-          <a:xfrm>
-            <a:off x="4636008" y="5349240"/>
+          <p:cNvPr id="36" name="Text 33"/>
+          <p:cNvSpPr/>
+          <p:nvPr/>
+        </p:nvSpPr>
+        <p:spPr>
+          <a:xfrm>
+            <a:off x="4636008" y="5513832"/>
             <a:ext cx="1005840" cy="256032"/>
           </a:xfrm>
           <a:prstGeom prst="rect">
@@ -2278,13 +2468,13 @@
       </p:sp>
       <p:sp>
         <p:nvSpPr>
-          <p:cNvPr id="36" name="Shape 34"/>
-          <p:cNvSpPr/>
-          <p:nvPr/>
-        </p:nvSpPr>
-        <p:spPr>
-          <a:xfrm>
-            <a:off x="5577840" y="5394960"/>
+          <p:cNvPr id="37" name="Shape 34"/>
+          <p:cNvSpPr/>
+          <p:nvPr/>
+        </p:nvSpPr>
+        <p:spPr>
+          <a:xfrm>
+            <a:off x="5577840" y="5559552"/>
             <a:ext cx="164592" cy="164592"/>
           </a:xfrm>
           <a:prstGeom prst="rect">
@@ -2303,13 +2493,13 @@
       </p:sp>
       <p:sp>
         <p:nvSpPr>
-          <p:cNvPr id="37" name="Text 35"/>
-          <p:cNvSpPr/>
-          <p:nvPr/>
-        </p:nvSpPr>
-        <p:spPr>
-          <a:xfrm>
-            <a:off x="5779008" y="5349240"/>
+          <p:cNvPr id="38" name="Text 35"/>
+          <p:cNvSpPr/>
+          <p:nvPr/>
+        </p:nvSpPr>
+        <p:spPr>
+          <a:xfrm>
+            <a:off x="5779008" y="5513832"/>
             <a:ext cx="1005840" cy="256032"/>
           </a:xfrm>
           <a:prstGeom prst="rect">
@@ -2342,13 +2532,13 @@
       </p:sp>
       <p:sp>
         <p:nvSpPr>
-          <p:cNvPr id="38" name="Shape 36"/>
-          <p:cNvSpPr/>
-          <p:nvPr/>
-        </p:nvSpPr>
-        <p:spPr>
-          <a:xfrm>
-            <a:off x="6720840" y="5394960"/>
+          <p:cNvPr id="39" name="Shape 36"/>
+          <p:cNvSpPr/>
+          <p:nvPr/>
+        </p:nvSpPr>
+        <p:spPr>
+          <a:xfrm>
+            <a:off x="6720840" y="5559552"/>
             <a:ext cx="164592" cy="164592"/>
           </a:xfrm>
           <a:prstGeom prst="rect">
@@ -2367,13 +2557,13 @@
       </p:sp>
       <p:sp>
         <p:nvSpPr>
-          <p:cNvPr id="39" name="Text 37"/>
-          <p:cNvSpPr/>
-          <p:nvPr/>
-        </p:nvSpPr>
-        <p:spPr>
-          <a:xfrm>
-            <a:off x="6922008" y="5349240"/>
+          <p:cNvPr id="40" name="Text 37"/>
+          <p:cNvSpPr/>
+          <p:nvPr/>
+        </p:nvSpPr>
+        <p:spPr>
+          <a:xfrm>
+            <a:off x="6922008" y="5513832"/>
             <a:ext cx="1005840" cy="256032"/>
           </a:xfrm>
           <a:prstGeom prst="rect">
@@ -2406,7 +2596,7 @@
       </p:sp>
       <p:sp>
         <p:nvSpPr>
-          <p:cNvPr id="40" name="Shape 38"/>
+          <p:cNvPr id="41" name="Shape 38"/>
           <p:cNvSpPr/>
           <p:nvPr/>
         </p:nvSpPr>
@@ -2433,7 +2623,7 @@
       </p:sp>
       <p:sp>
         <p:nvSpPr>
-          <p:cNvPr id="41" name="Text 39"/>
+          <p:cNvPr id="42" name="Text 39"/>
           <p:cNvSpPr/>
           <p:nvPr/>
         </p:nvSpPr>
@@ -2472,14 +2662,14 @@
       </p:sp>
       <p:sp>
         <p:nvSpPr>
-          <p:cNvPr id="42" name="Text 40"/>
-          <p:cNvSpPr/>
-          <p:nvPr/>
-        </p:nvSpPr>
-        <p:spPr>
-          <a:xfrm>
-            <a:off x="8229600" y="1627632"/>
-            <a:ext cx="3474720" cy="274320"/>
+          <p:cNvPr id="43" name="Text 40"/>
+          <p:cNvSpPr/>
+          <p:nvPr/>
+        </p:nvSpPr>
+        <p:spPr>
+          <a:xfrm>
+            <a:off x="8229600" y="1828800"/>
+            <a:ext cx="3474720" cy="457200"/>
           </a:xfrm>
           <a:prstGeom prst="rect">
             <a:avLst/>
@@ -2495,7 +2685,7 @@
               <a:buNone/>
             </a:pPr>
             <a:r>
-              <a:rPr lang="en-US" sz="1000" i="1" dirty="0">
+              <a:rPr lang="en-US" sz="900" dirty="0">
                 <a:solidFill>
                   <a:srgbClr val="6B7280"/>
                 </a:solidFill>
@@ -2503,21 +2693,21 @@
                 <a:ea typeface="Calibri" pitchFamily="34" charset="-122"/>
                 <a:cs typeface="Calibri" pitchFamily="34" charset="-120"/>
               </a:rPr>
-              <a:t>Mostly non-booking flows • Growing daily</a:t>
-            </a:r>
-            <a:endParaRPr lang="en-US" sz="1000" dirty="0"/>
-          </a:p>
-        </p:txBody>
-      </p:sp>
-      <p:sp>
-        <p:nvSpPr>
-          <p:cNvPr id="43" name="Shape 41"/>
-          <p:cNvSpPr/>
-          <p:nvPr/>
-        </p:nvSpPr>
-        <p:spPr>
-          <a:xfrm>
-            <a:off x="8229600" y="2011680"/>
+              <a:t>Passing rate depends on supplier availability, environment speed, and administration — reviewed regularly to stay reliable and grow coverage.</a:t>
+            </a:r>
+            <a:endParaRPr lang="en-US" sz="900" dirty="0"/>
+          </a:p>
+        </p:txBody>
+      </p:sp>
+      <p:sp>
+        <p:nvSpPr>
+          <p:cNvPr id="44" name="Shape 41"/>
+          <p:cNvSpPr/>
+          <p:nvPr/>
+        </p:nvSpPr>
+        <p:spPr>
+          <a:xfrm>
+            <a:off x="8229600" y="2377440"/>
             <a:ext cx="3429000" cy="685800"/>
           </a:xfrm>
           <a:prstGeom prst="roundRect">
@@ -2538,13 +2728,13 @@
       </p:sp>
       <p:sp>
         <p:nvSpPr>
-          <p:cNvPr id="44" name="Text 42"/>
-          <p:cNvSpPr/>
-          <p:nvPr/>
-        </p:nvSpPr>
-        <p:spPr>
-          <a:xfrm>
-            <a:off x="8321040" y="2057400"/>
+          <p:cNvPr id="45" name="Text 42"/>
+          <p:cNvSpPr/>
+          <p:nvPr/>
+        </p:nvSpPr>
+        <p:spPr>
+          <a:xfrm>
+            <a:off x="8321040" y="2423160"/>
             <a:ext cx="1828800" cy="594360"/>
           </a:xfrm>
           <a:prstGeom prst="rect">
@@ -2569,7 +2759,7 @@
                 <a:ea typeface="Calibri" pitchFamily="34" charset="-122"/>
                 <a:cs typeface="Calibri" pitchFamily="34" charset="-120"/>
               </a:rPr>
-              <a:t>189</a:t>
+              <a:t>340</a:t>
             </a:r>
             <a:endParaRPr lang="en-US" sz="2200" dirty="0"/>
           </a:p>
@@ -2577,13 +2767,13 @@
       </p:sp>
       <p:sp>
         <p:nvSpPr>
-          <p:cNvPr id="45" name="Text 43"/>
-          <p:cNvSpPr/>
-          <p:nvPr/>
-        </p:nvSpPr>
-        <p:spPr>
-          <a:xfrm>
-            <a:off x="9875520" y="2057400"/>
+          <p:cNvPr id="46" name="Text 43"/>
+          <p:cNvSpPr/>
+          <p:nvPr/>
+        </p:nvSpPr>
+        <p:spPr>
+          <a:xfrm>
+            <a:off x="9875520" y="2423160"/>
             <a:ext cx="1691640" cy="594360"/>
           </a:xfrm>
           <a:prstGeom prst="rect">
@@ -2616,13 +2806,13 @@
       </p:sp>
       <p:sp>
         <p:nvSpPr>
-          <p:cNvPr id="46" name="Shape 44"/>
-          <p:cNvSpPr/>
-          <p:nvPr/>
-        </p:nvSpPr>
-        <p:spPr>
-          <a:xfrm>
-            <a:off x="8229600" y="2788920"/>
+          <p:cNvPr id="47" name="Shape 44"/>
+          <p:cNvSpPr/>
+          <p:nvPr/>
+        </p:nvSpPr>
+        <p:spPr>
+          <a:xfrm>
+            <a:off x="8229600" y="3108960"/>
             <a:ext cx="3429000" cy="685800"/>
           </a:xfrm>
           <a:prstGeom prst="roundRect">
@@ -2643,13 +2833,13 @@
       </p:sp>
       <p:sp>
         <p:nvSpPr>
-          <p:cNvPr id="47" name="Text 45"/>
-          <p:cNvSpPr/>
-          <p:nvPr/>
-        </p:nvSpPr>
-        <p:spPr>
-          <a:xfrm>
-            <a:off x="8321040" y="2834640"/>
+          <p:cNvPr id="48" name="Text 45"/>
+          <p:cNvSpPr/>
+          <p:nvPr/>
+        </p:nvSpPr>
+        <p:spPr>
+          <a:xfrm>
+            <a:off x="8321040" y="3154680"/>
             <a:ext cx="1828800" cy="594360"/>
           </a:xfrm>
           <a:prstGeom prst="rect">
@@ -2674,7 +2864,7 @@
                 <a:ea typeface="Calibri" pitchFamily="34" charset="-122"/>
                 <a:cs typeface="Calibri" pitchFamily="34" charset="-120"/>
               </a:rPr>
-              <a:t>86.52%</a:t>
+              <a:t>82.50%</a:t>
             </a:r>
             <a:endParaRPr lang="en-US" sz="2200" dirty="0"/>
           </a:p>
@@ -2682,13 +2872,13 @@
       </p:sp>
       <p:sp>
         <p:nvSpPr>
-          <p:cNvPr id="48" name="Text 46"/>
-          <p:cNvSpPr/>
-          <p:nvPr/>
-        </p:nvSpPr>
-        <p:spPr>
-          <a:xfrm>
-            <a:off x="9875520" y="2834640"/>
+          <p:cNvPr id="49" name="Text 46"/>
+          <p:cNvSpPr/>
+          <p:nvPr/>
+        </p:nvSpPr>
+        <p:spPr>
+          <a:xfrm>
+            <a:off x="9875520" y="3154680"/>
             <a:ext cx="1691640" cy="594360"/>
           </a:xfrm>
           <a:prstGeom prst="rect">
@@ -2721,13 +2911,13 @@
       </p:sp>
       <p:sp>
         <p:nvSpPr>
-          <p:cNvPr id="49" name="Shape 47"/>
-          <p:cNvSpPr/>
-          <p:nvPr/>
-        </p:nvSpPr>
-        <p:spPr>
-          <a:xfrm>
-            <a:off x="8229600" y="3566160"/>
+          <p:cNvPr id="50" name="Shape 47"/>
+          <p:cNvSpPr/>
+          <p:nvPr/>
+        </p:nvSpPr>
+        <p:spPr>
+          <a:xfrm>
+            <a:off x="8229600" y="3840480"/>
             <a:ext cx="3429000" cy="685800"/>
           </a:xfrm>
           <a:prstGeom prst="roundRect">
@@ -2748,13 +2938,13 @@
       </p:sp>
       <p:sp>
         <p:nvSpPr>
-          <p:cNvPr id="50" name="Text 48"/>
-          <p:cNvSpPr/>
-          <p:nvPr/>
-        </p:nvSpPr>
-        <p:spPr>
-          <a:xfrm>
-            <a:off x="8321040" y="3611880"/>
+          <p:cNvPr id="51" name="Text 48"/>
+          <p:cNvSpPr/>
+          <p:nvPr/>
+        </p:nvSpPr>
+        <p:spPr>
+          <a:xfrm>
+            <a:off x="8321040" y="3886200"/>
             <a:ext cx="1828800" cy="594360"/>
           </a:xfrm>
           <a:prstGeom prst="rect">
@@ -2779,7 +2969,7 @@
                 <a:ea typeface="Calibri" pitchFamily="34" charset="-122"/>
                 <a:cs typeface="Calibri" pitchFamily="34" charset="-120"/>
               </a:rPr>
-              <a:t>26 min</a:t>
+              <a:t>50 min</a:t>
             </a:r>
             <a:endParaRPr lang="en-US" sz="2200" dirty="0"/>
           </a:p>
@@ -2787,13 +2977,13 @@
       </p:sp>
       <p:sp>
         <p:nvSpPr>
-          <p:cNvPr id="51" name="Text 49"/>
-          <p:cNvSpPr/>
-          <p:nvPr/>
-        </p:nvSpPr>
-        <p:spPr>
-          <a:xfrm>
-            <a:off x="9875520" y="3611880"/>
+          <p:cNvPr id="52" name="Text 49"/>
+          <p:cNvSpPr/>
+          <p:nvPr/>
+        </p:nvSpPr>
+        <p:spPr>
+          <a:xfrm>
+            <a:off x="9875520" y="3886200"/>
             <a:ext cx="1691640" cy="594360"/>
           </a:xfrm>
           <a:prstGeom prst="rect">
@@ -2826,13 +3016,13 @@
       </p:sp>
       <p:sp>
         <p:nvSpPr>
-          <p:cNvPr id="52" name="Text 50"/>
-          <p:cNvSpPr/>
-          <p:nvPr/>
-        </p:nvSpPr>
-        <p:spPr>
-          <a:xfrm>
-            <a:off x="8229600" y="4434840"/>
+          <p:cNvPr id="53" name="Text 50"/>
+          <p:cNvSpPr/>
+          <p:nvPr/>
+        </p:nvSpPr>
+        <p:spPr>
+          <a:xfrm>
+            <a:off x="8229600" y="4572000"/>
             <a:ext cx="3474720" cy="274320"/>
           </a:xfrm>
           <a:prstGeom prst="rect">
@@ -2865,13 +3055,13 @@
       </p:sp>
       <p:sp>
         <p:nvSpPr>
-          <p:cNvPr id="53" name="Text 51"/>
-          <p:cNvSpPr/>
-          <p:nvPr/>
-        </p:nvSpPr>
-        <p:spPr>
-          <a:xfrm>
-            <a:off x="8229600" y="4754880"/>
+          <p:cNvPr id="54" name="Text 51"/>
+          <p:cNvSpPr/>
+          <p:nvPr/>
+        </p:nvSpPr>
+        <p:spPr>
+          <a:xfrm>
+            <a:off x="8229600" y="4892040"/>
             <a:ext cx="914400" cy="256032"/>
           </a:xfrm>
           <a:prstGeom prst="rect">
@@ -2904,13 +3094,13 @@
       </p:sp>
       <p:sp>
         <p:nvSpPr>
-          <p:cNvPr id="54" name="Shape 52"/>
-          <p:cNvSpPr/>
-          <p:nvPr/>
-        </p:nvSpPr>
-        <p:spPr>
-          <a:xfrm>
-            <a:off x="9098280" y="4800600"/>
+          <p:cNvPr id="55" name="Shape 52"/>
+          <p:cNvSpPr/>
+          <p:nvPr/>
+        </p:nvSpPr>
+        <p:spPr>
+          <a:xfrm>
+            <a:off x="9098280" y="4937760"/>
             <a:ext cx="2011680" cy="164592"/>
           </a:xfrm>
           <a:prstGeom prst="roundRect">
@@ -2931,14 +3121,14 @@
       </p:sp>
       <p:sp>
         <p:nvSpPr>
-          <p:cNvPr id="55" name="Shape 53"/>
-          <p:cNvSpPr/>
-          <p:nvPr/>
-        </p:nvSpPr>
-        <p:spPr>
-          <a:xfrm>
-            <a:off x="9098280" y="4800600"/>
-            <a:ext cx="1075025" cy="164592"/>
+          <p:cNvPr id="56" name="Shape 53"/>
+          <p:cNvSpPr/>
+          <p:nvPr/>
+        </p:nvSpPr>
+        <p:spPr>
+          <a:xfrm>
+            <a:off x="9098280" y="4937760"/>
+            <a:ext cx="1212925" cy="164592"/>
           </a:xfrm>
           <a:prstGeom prst="roundRect">
             <a:avLst>
@@ -2958,13 +3148,13 @@
       </p:sp>
       <p:sp>
         <p:nvSpPr>
-          <p:cNvPr id="56" name="Text 54"/>
-          <p:cNvSpPr/>
-          <p:nvPr/>
-        </p:nvSpPr>
-        <p:spPr>
-          <a:xfrm>
-            <a:off x="11155680" y="4754880"/>
+          <p:cNvPr id="57" name="Text 54"/>
+          <p:cNvSpPr/>
+          <p:nvPr/>
+        </p:nvSpPr>
+        <p:spPr>
+          <a:xfrm>
+            <a:off x="11155680" y="4892040"/>
             <a:ext cx="502920" cy="256032"/>
           </a:xfrm>
           <a:prstGeom prst="rect">
@@ -2989,7 +3179,7 @@
                 <a:ea typeface="Calibri" pitchFamily="34" charset="-122"/>
                 <a:cs typeface="Calibri" pitchFamily="34" charset="-120"/>
               </a:rPr>
-              <a:t>101</a:t>
+              <a:t>205</a:t>
             </a:r>
             <a:endParaRPr lang="en-US" sz="1100" dirty="0"/>
           </a:p>
@@ -2997,13 +3187,13 @@
       </p:sp>
       <p:sp>
         <p:nvSpPr>
-          <p:cNvPr id="57" name="Text 55"/>
-          <p:cNvSpPr/>
-          <p:nvPr/>
-        </p:nvSpPr>
-        <p:spPr>
-          <a:xfrm>
-            <a:off x="8229600" y="5102352"/>
+          <p:cNvPr id="58" name="Text 55"/>
+          <p:cNvSpPr/>
+          <p:nvPr/>
+        </p:nvSpPr>
+        <p:spPr>
+          <a:xfrm>
+            <a:off x="8229600" y="5239512"/>
             <a:ext cx="914400" cy="256032"/>
           </a:xfrm>
           <a:prstGeom prst="rect">
@@ -3036,13 +3226,13 @@
       </p:sp>
       <p:sp>
         <p:nvSpPr>
-          <p:cNvPr id="58" name="Shape 56"/>
-          <p:cNvSpPr/>
-          <p:nvPr/>
-        </p:nvSpPr>
-        <p:spPr>
-          <a:xfrm>
-            <a:off x="9098280" y="5148072"/>
+          <p:cNvPr id="59" name="Shape 56"/>
+          <p:cNvSpPr/>
+          <p:nvPr/>
+        </p:nvSpPr>
+        <p:spPr>
+          <a:xfrm>
+            <a:off x="9098280" y="5285232"/>
             <a:ext cx="2011680" cy="164592"/>
           </a:xfrm>
           <a:prstGeom prst="roundRect">
@@ -3063,14 +3253,14 @@
       </p:sp>
       <p:sp>
         <p:nvSpPr>
-          <p:cNvPr id="59" name="Shape 57"/>
-          <p:cNvSpPr/>
-          <p:nvPr/>
-        </p:nvSpPr>
-        <p:spPr>
-          <a:xfrm>
-            <a:off x="9098280" y="5148072"/>
-            <a:ext cx="819573" cy="164592"/>
+          <p:cNvPr id="60" name="Shape 57"/>
+          <p:cNvSpPr/>
+          <p:nvPr/>
+        </p:nvSpPr>
+        <p:spPr>
+          <a:xfrm>
+            <a:off x="9098280" y="5285232"/>
+            <a:ext cx="656754" cy="164592"/>
           </a:xfrm>
           <a:prstGeom prst="roundRect">
             <a:avLst>
@@ -3090,13 +3280,13 @@
       </p:sp>
       <p:sp>
         <p:nvSpPr>
-          <p:cNvPr id="60" name="Text 58"/>
-          <p:cNvSpPr/>
-          <p:nvPr/>
-        </p:nvSpPr>
-        <p:spPr>
-          <a:xfrm>
-            <a:off x="11155680" y="5102352"/>
+          <p:cNvPr id="61" name="Text 58"/>
+          <p:cNvSpPr/>
+          <p:nvPr/>
+        </p:nvSpPr>
+        <p:spPr>
+          <a:xfrm>
+            <a:off x="11155680" y="5239512"/>
             <a:ext cx="502920" cy="256032"/>
           </a:xfrm>
           <a:prstGeom prst="rect">
@@ -3121,7 +3311,7 @@
                 <a:ea typeface="Calibri" pitchFamily="34" charset="-122"/>
                 <a:cs typeface="Calibri" pitchFamily="34" charset="-120"/>
               </a:rPr>
-              <a:t>77</a:t>
+              <a:t>111</a:t>
             </a:r>
             <a:endParaRPr lang="en-US" sz="1100" dirty="0"/>
           </a:p>
@@ -3129,13 +3319,13 @@
       </p:sp>
       <p:sp>
         <p:nvSpPr>
-          <p:cNvPr id="61" name="Text 59"/>
-          <p:cNvSpPr/>
-          <p:nvPr/>
-        </p:nvSpPr>
-        <p:spPr>
-          <a:xfrm>
-            <a:off x="8229600" y="5449824"/>
+          <p:cNvPr id="62" name="Text 59"/>
+          <p:cNvSpPr/>
+          <p:nvPr/>
+        </p:nvSpPr>
+        <p:spPr>
+          <a:xfrm>
+            <a:off x="8229600" y="5586984"/>
             <a:ext cx="914400" cy="256032"/>
           </a:xfrm>
           <a:prstGeom prst="rect">
@@ -3160,7 +3350,7 @@
                 <a:ea typeface="Calibri" pitchFamily="34" charset="-122"/>
                 <a:cs typeface="Calibri" pitchFamily="34" charset="-120"/>
               </a:rPr>
-              <a:t>Cars</a:t>
+              <a:t>Transportation</a:t>
             </a:r>
             <a:endParaRPr lang="en-US" sz="1100" dirty="0"/>
           </a:p>
@@ -3168,13 +3358,13 @@
       </p:sp>
       <p:sp>
         <p:nvSpPr>
-          <p:cNvPr id="62" name="Shape 60"/>
-          <p:cNvSpPr/>
-          <p:nvPr/>
-        </p:nvSpPr>
-        <p:spPr>
-          <a:xfrm>
-            <a:off x="9098280" y="5495544"/>
+          <p:cNvPr id="63" name="Shape 60"/>
+          <p:cNvSpPr/>
+          <p:nvPr/>
+        </p:nvSpPr>
+        <p:spPr>
+          <a:xfrm>
+            <a:off x="9098280" y="5632704"/>
             <a:ext cx="2011680" cy="164592"/>
           </a:xfrm>
           <a:prstGeom prst="roundRect">
@@ -3195,18 +3385,18 @@
       </p:sp>
       <p:sp>
         <p:nvSpPr>
-          <p:cNvPr id="63" name="Shape 61"/>
-          <p:cNvSpPr/>
-          <p:nvPr/>
-        </p:nvSpPr>
-        <p:spPr>
-          <a:xfrm>
-            <a:off x="9098280" y="5495544"/>
-            <a:ext cx="95794" cy="164592"/>
+          <p:cNvPr id="64" name="Shape 61"/>
+          <p:cNvSpPr/>
+          <p:nvPr/>
+        </p:nvSpPr>
+        <p:spPr>
+          <a:xfrm>
+            <a:off x="9098280" y="5632704"/>
+            <a:ext cx="142001" cy="164592"/>
           </a:xfrm>
           <a:prstGeom prst="roundRect">
             <a:avLst>
-              <a:gd name="adj" fmla="val 38182"/>
+              <a:gd name="adj" fmla="val 25758"/>
             </a:avLst>
           </a:prstGeom>
           <a:solidFill>
@@ -3222,13 +3412,13 @@
       </p:sp>
       <p:sp>
         <p:nvSpPr>
-          <p:cNvPr id="64" name="Text 62"/>
-          <p:cNvSpPr/>
-          <p:nvPr/>
-        </p:nvSpPr>
-        <p:spPr>
-          <a:xfrm>
-            <a:off x="11155680" y="5449824"/>
+          <p:cNvPr id="65" name="Text 62"/>
+          <p:cNvSpPr/>
+          <p:nvPr/>
+        </p:nvSpPr>
+        <p:spPr>
+          <a:xfrm>
+            <a:off x="11155680" y="5586984"/>
             <a:ext cx="502920" cy="256032"/>
           </a:xfrm>
           <a:prstGeom prst="rect">
@@ -3253,7 +3443,7 @@
                 <a:ea typeface="Calibri" pitchFamily="34" charset="-122"/>
                 <a:cs typeface="Calibri" pitchFamily="34" charset="-120"/>
               </a:rPr>
-              <a:t>9</a:t>
+              <a:t>24</a:t>
             </a:r>
             <a:endParaRPr lang="en-US" sz="1100" dirty="0"/>
           </a:p>
@@ -3261,139 +3451,7 @@
       </p:sp>
       <p:sp>
         <p:nvSpPr>
-          <p:cNvPr id="65" name="Text 63"/>
-          <p:cNvSpPr/>
-          <p:nvPr/>
-        </p:nvSpPr>
-        <p:spPr>
-          <a:xfrm>
-            <a:off x="8229600" y="5797296"/>
-            <a:ext cx="914400" cy="256032"/>
-          </a:xfrm>
-          <a:prstGeom prst="rect">
-            <a:avLst/>
-          </a:prstGeom>
-          <a:noFill/>
-          <a:ln/>
-        </p:spPr>
-        <p:txBody>
-          <a:bodyPr wrap="square" rtlCol="0" anchor="ctr"/>
-          <a:lstStyle/>
-          <a:p>
-            <a:pPr indent="0" marL="0">
-              <a:buNone/>
-            </a:pPr>
-            <a:r>
-              <a:rPr lang="en-US" sz="1100" dirty="0">
-                <a:solidFill>
-                  <a:srgbClr val="1F2937"/>
-                </a:solidFill>
-                <a:latin typeface="Calibri" pitchFamily="34" charset="0"/>
-                <a:ea typeface="Calibri" pitchFamily="34" charset="-122"/>
-                <a:cs typeface="Calibri" pitchFamily="34" charset="-120"/>
-              </a:rPr>
-              <a:t>Rails</a:t>
-            </a:r>
-            <a:endParaRPr lang="en-US" sz="1100" dirty="0"/>
-          </a:p>
-        </p:txBody>
-      </p:sp>
-      <p:sp>
-        <p:nvSpPr>
-          <p:cNvPr id="66" name="Shape 64"/>
-          <p:cNvSpPr/>
-          <p:nvPr/>
-        </p:nvSpPr>
-        <p:spPr>
-          <a:xfrm>
-            <a:off x="9098280" y="5843016"/>
-            <a:ext cx="2011680" cy="164592"/>
-          </a:xfrm>
-          <a:prstGeom prst="roundRect">
-            <a:avLst>
-              <a:gd name="adj" fmla="val 22222"/>
-            </a:avLst>
-          </a:prstGeom>
-          <a:solidFill>
-            <a:srgbClr val="E5E7EB"/>
-          </a:solidFill>
-          <a:ln w="12700">
-            <a:solidFill>
-              <a:srgbClr val="E5E7EB"/>
-            </a:solidFill>
-            <a:prstDash val="solid"/>
-          </a:ln>
-        </p:spPr>
-      </p:sp>
-      <p:sp>
-        <p:nvSpPr>
-          <p:cNvPr id="67" name="Shape 65"/>
-          <p:cNvSpPr/>
-          <p:nvPr/>
-        </p:nvSpPr>
-        <p:spPr>
-          <a:xfrm>
-            <a:off x="9098280" y="5843016"/>
-            <a:ext cx="45720" cy="164592"/>
-          </a:xfrm>
-          <a:prstGeom prst="roundRect">
-            <a:avLst>
-              <a:gd name="adj" fmla="val 80000"/>
-            </a:avLst>
-          </a:prstGeom>
-          <a:solidFill>
-            <a:srgbClr val="2563EB"/>
-          </a:solidFill>
-          <a:ln w="12700">
-            <a:solidFill>
-              <a:srgbClr val="2563EB"/>
-            </a:solidFill>
-            <a:prstDash val="solid"/>
-          </a:ln>
-        </p:spPr>
-      </p:sp>
-      <p:sp>
-        <p:nvSpPr>
-          <p:cNvPr id="68" name="Text 66"/>
-          <p:cNvSpPr/>
-          <p:nvPr/>
-        </p:nvSpPr>
-        <p:spPr>
-          <a:xfrm>
-            <a:off x="11155680" y="5797296"/>
-            <a:ext cx="502920" cy="256032"/>
-          </a:xfrm>
-          <a:prstGeom prst="rect">
-            <a:avLst/>
-          </a:prstGeom>
-          <a:noFill/>
-          <a:ln/>
-        </p:spPr>
-        <p:txBody>
-          <a:bodyPr wrap="square" rtlCol="0" anchor="ctr"/>
-          <a:lstStyle/>
-          <a:p>
-            <a:pPr algn="r" indent="0" marL="0">
-              <a:buNone/>
-            </a:pPr>
-            <a:r>
-              <a:rPr lang="en-US" sz="1100" b="1" dirty="0">
-                <a:solidFill>
-                  <a:srgbClr val="1F2937"/>
-                </a:solidFill>
-                <a:latin typeface="Calibri" pitchFamily="34" charset="0"/>
-                <a:ea typeface="Calibri" pitchFamily="34" charset="-122"/>
-                <a:cs typeface="Calibri" pitchFamily="34" charset="-120"/>
-              </a:rPr>
-              <a:t>2</a:t>
-            </a:r>
-            <a:endParaRPr lang="en-US" sz="1100" dirty="0"/>
-          </a:p>
-        </p:txBody>
-      </p:sp>
-      <p:sp>
-        <p:nvSpPr>
-          <p:cNvPr id="69" name="Text 67"/>
+          <p:cNvPr id="66" name="Text 63"/>
           <p:cNvSpPr/>
           <p:nvPr/>
         </p:nvSpPr>

</xml_diff>

<commit_message>
docs(docs): update migration progress slide for sprint 13
- Bump overall migration to 68% (499/739 tests)
- Shell migration up to 50% (102/204)
- Refresh KPI tiles and composition counts
</commit_message>
<xml_diff>
--- a/docs/Test-Migration-Progress.pptx
+++ b/docs/Test-Migration-Progress.pptx
@@ -188,9 +188,9 @@
           </c:marker>
           <c:cat>
             <c:multiLvlStrRef>
-              <c:f>Sheet1!$A$2:$A$4</c:f>
+              <c:f>Sheet1!$A$2:$A$6</c:f>
               <c:multiLvlStrCache>
-                <c:ptCount val="3"/>
+                <c:ptCount val="5"/>
                 <c:lvl>
                   <c:pt idx="0">
                     <c:v>Sprint 9</c:v>
@@ -201,16 +201,22 @@
                   <c:pt idx="2">
                     <c:v>Sprint 11</c:v>
                   </c:pt>
+                  <c:pt idx="3">
+                    <c:v>Sprint 12</c:v>
+                  </c:pt>
+                  <c:pt idx="4">
+                    <c:v>Sprint 13</c:v>
+                  </c:pt>
                 </c:lvl>
               </c:multiLvlStrCache>
             </c:multiLvlStrRef>
           </c:cat>
           <c:val>
             <c:numRef>
-              <c:f>Sheet1!$B$2:$B$4</c:f>
+              <c:f>Sheet1!$B$2:$B$6</c:f>
               <c:numCache>
                 <c:formatCode>General</c:formatCode>
-                <c:ptCount val="3"/>
+                <c:ptCount val="5"/>
                 <c:pt idx="0">
                   <c:v>45</c:v>
                 </c:pt>
@@ -219,6 +225,12 @@
                 </c:pt>
                 <c:pt idx="2">
                   <c:v>63</c:v>
+                </c:pt>
+                <c:pt idx="3">
+                  <c:v>63</c:v>
+                </c:pt>
+                <c:pt idx="4">
+                  <c:v>68</c:v>
                 </c:pt>
               </c:numCache>
             </c:numRef>
@@ -1601,7 +1613,7 @@
                 <a:ea typeface="Calibri" pitchFamily="34" charset="-122"/>
                 <a:cs typeface="Calibri" pitchFamily="34" charset="-120"/>
               </a:rPr>
-              <a:t>63%</a:t>
+              <a:t>68%</a:t>
             </a:r>
             <a:endParaRPr lang="en-US" sz="6400" dirty="0"/>
           </a:p>
@@ -1640,7 +1652,7 @@
                 <a:ea typeface="Calibri" pitchFamily="34" charset="-122"/>
                 <a:cs typeface="Calibri" pitchFamily="34" charset="-120"/>
               </a:rPr>
-              <a:t>464 / 739 tests migrated</a:t>
+              <a:t>499 / 739 tests migrated</a:t>
             </a:r>
             <a:endParaRPr lang="en-US" sz="1300" dirty="0"/>
           </a:p>
@@ -2270,7 +2282,7 @@
                 <a:ea typeface="Calibri" pitchFamily="34" charset="-122"/>
                 <a:cs typeface="Calibri" pitchFamily="34" charset="-120"/>
               </a:rPr>
-              <a:t>67/204</a:t>
+              <a:t>102/204</a:t>
             </a:r>
             <a:endParaRPr lang="en-US" sz="1000" dirty="0"/>
           </a:p>
@@ -2309,7 +2321,7 @@
                 <a:ea typeface="Calibri" pitchFamily="34" charset="-122"/>
                 <a:cs typeface="Calibri" pitchFamily="34" charset="-120"/>
               </a:rPr>
-              <a:t>33%</a:t>
+              <a:t>50%</a:t>
             </a:r>
             <a:endParaRPr lang="en-US" sz="1100" dirty="0"/>
           </a:p>
@@ -2351,7 +2363,7 @@
         <p:spPr>
           <a:xfrm>
             <a:off x="4434840" y="4873752"/>
-            <a:ext cx="1116482" cy="182880"/>
+            <a:ext cx="1691640" cy="182880"/>
           </a:xfrm>
           <a:prstGeom prst="roundRect">
             <a:avLst>
@@ -2402,7 +2414,7 @@
                 <a:ea typeface="Calibri" pitchFamily="34" charset="-122"/>
                 <a:cs typeface="Calibri" pitchFamily="34" charset="-120"/>
               </a:rPr>
-              <a:t>🚧 32 tests blocked (supplier errors / known bugs / require review)</a:t>
+              <a:t>🚧 33 tests blocked (supplier errors / known bugs / require review)</a:t>
             </a:r>
             <a:endParaRPr lang="en-US" sz="900" dirty="0"/>
           </a:p>
@@ -2765,7 +2777,7 @@
                 <a:ea typeface="Calibri" pitchFamily="34" charset="-122"/>
                 <a:cs typeface="Calibri" pitchFamily="34" charset="-120"/>
               </a:rPr>
-              <a:t>432</a:t>
+              <a:t>455</a:t>
             </a:r>
             <a:endParaRPr lang="en-US" sz="2200" dirty="0"/>
           </a:p>
@@ -2870,7 +2882,7 @@
                 <a:ea typeface="Calibri" pitchFamily="34" charset="-122"/>
                 <a:cs typeface="Calibri" pitchFamily="34" charset="-120"/>
               </a:rPr>
-              <a:t>82.50%</a:t>
+              <a:t>75%</a:t>
             </a:r>
             <a:endParaRPr lang="en-US" sz="2200" dirty="0"/>
           </a:p>
@@ -2975,7 +2987,7 @@
                 <a:ea typeface="Calibri" pitchFamily="34" charset="-122"/>
                 <a:cs typeface="Calibri" pitchFamily="34" charset="-120"/>
               </a:rPr>
-              <a:t>50 min</a:t>
+              <a:t>1h20min</a:t>
             </a:r>
             <a:endParaRPr lang="en-US" sz="2200" dirty="0"/>
           </a:p>
@@ -3134,7 +3146,7 @@
         <p:spPr>
           <a:xfrm>
             <a:off x="9098280" y="4937760"/>
-            <a:ext cx="1182793" cy="164592"/>
+            <a:ext cx="1224693" cy="164592"/>
           </a:xfrm>
           <a:prstGeom prst="roundRect">
             <a:avLst>
@@ -3185,7 +3197,7 @@
                 <a:ea typeface="Calibri" pitchFamily="34" charset="-122"/>
                 <a:cs typeface="Calibri" pitchFamily="34" charset="-120"/>
               </a:rPr>
-              <a:t>254</a:t>
+              <a:t>277</a:t>
             </a:r>
             <a:endParaRPr lang="en-US" sz="1100" dirty="0"/>
           </a:p>
@@ -3266,7 +3278,7 @@
         <p:spPr>
           <a:xfrm>
             <a:off x="9098280" y="5285232"/>
-            <a:ext cx="521547" cy="164592"/>
+            <a:ext cx="486340" cy="164592"/>
           </a:xfrm>
           <a:prstGeom prst="roundRect">
             <a:avLst>
@@ -3317,7 +3329,7 @@
                 <a:ea typeface="Calibri" pitchFamily="34" charset="-122"/>
                 <a:cs typeface="Calibri" pitchFamily="34" charset="-120"/>
               </a:rPr>
-              <a:t>112</a:t>
+              <a:t>110</a:t>
             </a:r>
             <a:endParaRPr lang="en-US" sz="1100" dirty="0"/>
           </a:p>
@@ -3398,11 +3410,11 @@
         <p:spPr>
           <a:xfrm>
             <a:off x="9098280" y="5632704"/>
-            <a:ext cx="130387" cy="164592"/>
+            <a:ext cx="132638" cy="164592"/>
           </a:xfrm>
           <a:prstGeom prst="roundRect">
             <a:avLst>
-              <a:gd name="adj" fmla="val 28052"/>
+              <a:gd name="adj" fmla="val 27576"/>
             </a:avLst>
           </a:prstGeom>
           <a:solidFill>
@@ -3449,7 +3461,7 @@
                 <a:ea typeface="Calibri" pitchFamily="34" charset="-122"/>
                 <a:cs typeface="Calibri" pitchFamily="34" charset="-120"/>
               </a:rPr>
-              <a:t>28</a:t>
+              <a:t>30</a:t>
             </a:r>
             <a:endParaRPr lang="en-US" sz="1100" dirty="0"/>
           </a:p>
@@ -3530,7 +3542,7 @@
         <p:spPr>
           <a:xfrm>
             <a:off x="9098280" y="5980176"/>
-            <a:ext cx="176953" cy="164592"/>
+            <a:ext cx="168008" cy="164592"/>
           </a:xfrm>
           <a:prstGeom prst="roundRect">
             <a:avLst>

</xml_diff>

<commit_message>
docs: refresh migration progress slide with sprint 14 figures
- Add Sprint 14 data point (74%) to the per-sprint trend chart
- Update overall migration to 74% (550 / 739) after Shell reached 153 done
- Correct Shell domain bar to 75% (153/204), previously left at 50%
- Update blocked-tests note to 42, counted from the flights/hotels/shell
  *_blocked folders (was 33)
- Regenerate docs/Test-Migration-Progress.pptx

Co-Authored-By: Claude Opus 4.8 (1M context) <noreply@anthropic.com>
</commit_message>
<xml_diff>
--- a/docs/Test-Migration-Progress.pptx
+++ b/docs/Test-Migration-Progress.pptx
@@ -188,9 +188,9 @@
           </c:marker>
           <c:cat>
             <c:multiLvlStrRef>
-              <c:f>Sheet1!$A$2:$A$6</c:f>
+              <c:f>Sheet1!$A$2:$A$7</c:f>
               <c:multiLvlStrCache>
-                <c:ptCount val="5"/>
+                <c:ptCount val="6"/>
                 <c:lvl>
                   <c:pt idx="0">
                     <c:v>Sprint 9</c:v>
@@ -207,16 +207,19 @@
                   <c:pt idx="4">
                     <c:v>Sprint 13</c:v>
                   </c:pt>
+                  <c:pt idx="5">
+                    <c:v>Sprint 14</c:v>
+                  </c:pt>
                 </c:lvl>
               </c:multiLvlStrCache>
             </c:multiLvlStrRef>
           </c:cat>
           <c:val>
             <c:numRef>
-              <c:f>Sheet1!$B$2:$B$6</c:f>
+              <c:f>Sheet1!$B$2:$B$7</c:f>
               <c:numCache>
                 <c:formatCode>General</c:formatCode>
-                <c:ptCount val="5"/>
+                <c:ptCount val="6"/>
                 <c:pt idx="0">
                   <c:v>45</c:v>
                 </c:pt>
@@ -231,6 +234,9 @@
                 </c:pt>
                 <c:pt idx="4">
                   <c:v>68</c:v>
+                </c:pt>
+                <c:pt idx="5">
+                  <c:v>74</c:v>
                 </c:pt>
               </c:numCache>
             </c:numRef>
@@ -1613,7 +1619,7 @@
                 <a:ea typeface="Calibri" pitchFamily="34" charset="-122"/>
                 <a:cs typeface="Calibri" pitchFamily="34" charset="-120"/>
               </a:rPr>
-              <a:t>68%</a:t>
+              <a:t>74%</a:t>
             </a:r>
             <a:endParaRPr lang="en-US" sz="6400" dirty="0"/>
           </a:p>
@@ -1652,7 +1658,7 @@
                 <a:ea typeface="Calibri" pitchFamily="34" charset="-122"/>
                 <a:cs typeface="Calibri" pitchFamily="34" charset="-120"/>
               </a:rPr>
-              <a:t>499 / 739 tests migrated</a:t>
+              <a:t>550 / 739 tests migrated</a:t>
             </a:r>
             <a:endParaRPr lang="en-US" sz="1300" dirty="0"/>
           </a:p>
@@ -2282,7 +2288,7 @@
                 <a:ea typeface="Calibri" pitchFamily="34" charset="-122"/>
                 <a:cs typeface="Calibri" pitchFamily="34" charset="-120"/>
               </a:rPr>
-              <a:t>102/204</a:t>
+              <a:t>153/204</a:t>
             </a:r>
             <a:endParaRPr lang="en-US" sz="1000" dirty="0"/>
           </a:p>
@@ -2321,7 +2327,7 @@
                 <a:ea typeface="Calibri" pitchFamily="34" charset="-122"/>
                 <a:cs typeface="Calibri" pitchFamily="34" charset="-120"/>
               </a:rPr>
-              <a:t>50%</a:t>
+              <a:t>75%</a:t>
             </a:r>
             <a:endParaRPr lang="en-US" sz="1100" dirty="0"/>
           </a:p>
@@ -2363,7 +2369,7 @@
         <p:spPr>
           <a:xfrm>
             <a:off x="4434840" y="4873752"/>
-            <a:ext cx="1691640" cy="182880"/>
+            <a:ext cx="2537460" cy="182880"/>
           </a:xfrm>
           <a:prstGeom prst="roundRect">
             <a:avLst>
@@ -2414,7 +2420,7 @@
                 <a:ea typeface="Calibri" pitchFamily="34" charset="-122"/>
                 <a:cs typeface="Calibri" pitchFamily="34" charset="-120"/>
               </a:rPr>
-              <a:t>🚧 33 tests blocked (supplier errors / known bugs / require review)</a:t>
+              <a:t>🚧 42 tests blocked (supplier errors / known bugs / require review)</a:t>
             </a:r>
             <a:endParaRPr lang="en-US" sz="900" dirty="0"/>
           </a:p>

</xml_diff>

<commit_message>
docs: sync migration slide daily-run figures and clarify blocked tests
- Update Daily Stability Run to actual suite counts: 555 tests running
  daily (Flights 270, Hotels 109, Transportation 26, Shell 150)
- Add note that the daily run is mostly migrated tests, with new tests
  continuously being added to grow coverage
- Shorten trend chart x-axis to sprint numbers only (9-14)
- Flag that the 42 blocked tests are not included in the overall
  migration count

Co-Authored-By: Claude Opus 4.8 (1M context) <noreply@anthropic.com>
</commit_message>
<xml_diff>
--- a/docs/Test-Migration-Progress.pptx
+++ b/docs/Test-Migration-Progress.pptx
@@ -193,22 +193,22 @@
                 <c:ptCount val="6"/>
                 <c:lvl>
                   <c:pt idx="0">
-                    <c:v>Sprint 9</c:v>
+                    <c:v>9</c:v>
                   </c:pt>
                   <c:pt idx="1">
-                    <c:v>Sprint 10</c:v>
+                    <c:v>10</c:v>
                   </c:pt>
                   <c:pt idx="2">
-                    <c:v>Sprint 11</c:v>
+                    <c:v>11</c:v>
                   </c:pt>
                   <c:pt idx="3">
-                    <c:v>Sprint 12</c:v>
+                    <c:v>12</c:v>
                   </c:pt>
                   <c:pt idx="4">
-                    <c:v>Sprint 13</c:v>
+                    <c:v>13</c:v>
                   </c:pt>
                   <c:pt idx="5">
-                    <c:v>Sprint 14</c:v>
+                    <c:v>14</c:v>
                   </c:pt>
                 </c:lvl>
               </c:multiLvlStrCache>
@@ -2396,7 +2396,7 @@
         <p:spPr>
           <a:xfrm>
             <a:off x="4434840" y="5193792"/>
-            <a:ext cx="3383280" cy="320040"/>
+            <a:ext cx="3383280" cy="457200"/>
           </a:xfrm>
           <a:prstGeom prst="rect">
             <a:avLst/>
@@ -2420,7 +2420,7 @@
                 <a:ea typeface="Calibri" pitchFamily="34" charset="-122"/>
                 <a:cs typeface="Calibri" pitchFamily="34" charset="-120"/>
               </a:rPr>
-              <a:t>🚧 42 tests blocked (supplier errors / known bugs / require review)</a:t>
+              <a:t>🚧 42 tests blocked (supplier errors / known bugs / require review) — not included in the overall migration count above</a:t>
             </a:r>
             <a:endParaRPr lang="en-US" sz="900" dirty="0"/>
           </a:p>
@@ -2434,7 +2434,7 @@
         </p:nvSpPr>
         <p:spPr>
           <a:xfrm>
-            <a:off x="4434840" y="5559552"/>
+            <a:off x="4434840" y="5742432"/>
             <a:ext cx="164592" cy="164592"/>
           </a:xfrm>
           <a:prstGeom prst="rect">
@@ -2459,7 +2459,7 @@
         </p:nvSpPr>
         <p:spPr>
           <a:xfrm>
-            <a:off x="4636008" y="5513832"/>
+            <a:off x="4636008" y="5696712"/>
             <a:ext cx="1005840" cy="256032"/>
           </a:xfrm>
           <a:prstGeom prst="rect">
@@ -2498,7 +2498,7 @@
         </p:nvSpPr>
         <p:spPr>
           <a:xfrm>
-            <a:off x="5577840" y="5559552"/>
+            <a:off x="5577840" y="5742432"/>
             <a:ext cx="164592" cy="164592"/>
           </a:xfrm>
           <a:prstGeom prst="rect">
@@ -2523,7 +2523,7 @@
         </p:nvSpPr>
         <p:spPr>
           <a:xfrm>
-            <a:off x="5779008" y="5513832"/>
+            <a:off x="5779008" y="5696712"/>
             <a:ext cx="1005840" cy="256032"/>
           </a:xfrm>
           <a:prstGeom prst="rect">
@@ -2562,7 +2562,7 @@
         </p:nvSpPr>
         <p:spPr>
           <a:xfrm>
-            <a:off x="6720840" y="5559552"/>
+            <a:off x="6720840" y="5742432"/>
             <a:ext cx="164592" cy="164592"/>
           </a:xfrm>
           <a:prstGeom prst="rect">
@@ -2587,7 +2587,7 @@
         </p:nvSpPr>
         <p:spPr>
           <a:xfrm>
-            <a:off x="6922008" y="5513832"/>
+            <a:off x="6922008" y="5696712"/>
             <a:ext cx="1005840" cy="256032"/>
           </a:xfrm>
           <a:prstGeom prst="rect">
@@ -2692,8 +2692,8 @@
         </p:nvSpPr>
         <p:spPr>
           <a:xfrm>
-            <a:off x="8229600" y="1828800"/>
-            <a:ext cx="3474720" cy="457200"/>
+            <a:off x="8229600" y="1691640"/>
+            <a:ext cx="3474720" cy="658368"/>
           </a:xfrm>
           <a:prstGeom prst="rect">
             <a:avLst/>
@@ -2717,7 +2717,7 @@
                 <a:ea typeface="Calibri" pitchFamily="34" charset="-122"/>
                 <a:cs typeface="Calibri" pitchFamily="34" charset="-120"/>
               </a:rPr>
-              <a:t>Passing rate depends on supplier availability, environment speed, and administration — reviewed regularly to stay reliable and grow coverage.</a:t>
+              <a:t>Mostly migrated tests, with new tests continuously being added to grow coverage. Passing rate depends on supplier availability, environment speed, and administration — reviewed regularly to stay reliable.</a:t>
             </a:r>
             <a:endParaRPr lang="en-US" sz="900" dirty="0"/>
           </a:p>
@@ -2783,7 +2783,7 @@
                 <a:ea typeface="Calibri" pitchFamily="34" charset="-122"/>
                 <a:cs typeface="Calibri" pitchFamily="34" charset="-120"/>
               </a:rPr>
-              <a:t>455</a:t>
+              <a:t>555</a:t>
             </a:r>
             <a:endParaRPr lang="en-US" sz="2200" dirty="0"/>
           </a:p>
@@ -3152,7 +3152,7 @@
         <p:spPr>
           <a:xfrm>
             <a:off x="9098280" y="4937760"/>
-            <a:ext cx="1224693" cy="164592"/>
+            <a:ext cx="978655" cy="164592"/>
           </a:xfrm>
           <a:prstGeom prst="roundRect">
             <a:avLst>
@@ -3203,7 +3203,7 @@
                 <a:ea typeface="Calibri" pitchFamily="34" charset="-122"/>
                 <a:cs typeface="Calibri" pitchFamily="34" charset="-120"/>
               </a:rPr>
-              <a:t>277</a:t>
+              <a:t>270</a:t>
             </a:r>
             <a:endParaRPr lang="en-US" sz="1100" dirty="0"/>
           </a:p>
@@ -3284,7 +3284,7 @@
         <p:spPr>
           <a:xfrm>
             <a:off x="9098280" y="5285232"/>
-            <a:ext cx="486340" cy="164592"/>
+            <a:ext cx="395087" cy="164592"/>
           </a:xfrm>
           <a:prstGeom prst="roundRect">
             <a:avLst>
@@ -3335,7 +3335,7 @@
                 <a:ea typeface="Calibri" pitchFamily="34" charset="-122"/>
                 <a:cs typeface="Calibri" pitchFamily="34" charset="-120"/>
               </a:rPr>
-              <a:t>110</a:t>
+              <a:t>109</a:t>
             </a:r>
             <a:endParaRPr lang="en-US" sz="1100" dirty="0"/>
           </a:p>
@@ -3416,11 +3416,11 @@
         <p:spPr>
           <a:xfrm>
             <a:off x="9098280" y="5632704"/>
-            <a:ext cx="132638" cy="164592"/>
+            <a:ext cx="94241" cy="164592"/>
           </a:xfrm>
           <a:prstGeom prst="roundRect">
             <a:avLst>
-              <a:gd name="adj" fmla="val 27576"/>
+              <a:gd name="adj" fmla="val 38811"/>
             </a:avLst>
           </a:prstGeom>
           <a:solidFill>
@@ -3467,7 +3467,7 @@
                 <a:ea typeface="Calibri" pitchFamily="34" charset="-122"/>
                 <a:cs typeface="Calibri" pitchFamily="34" charset="-120"/>
               </a:rPr>
-              <a:t>30</a:t>
+              <a:t>26</a:t>
             </a:r>
             <a:endParaRPr lang="en-US" sz="1100" dirty="0"/>
           </a:p>
@@ -3548,7 +3548,7 @@
         <p:spPr>
           <a:xfrm>
             <a:off x="9098280" y="5980176"/>
-            <a:ext cx="168008" cy="164592"/>
+            <a:ext cx="543697" cy="164592"/>
           </a:xfrm>
           <a:prstGeom prst="roundRect">
             <a:avLst>
@@ -3599,7 +3599,7 @@
                 <a:ea typeface="Calibri" pitchFamily="34" charset="-122"/>
                 <a:cs typeface="Calibri" pitchFamily="34" charset="-120"/>
               </a:rPr>
-              <a:t>38</a:t>
+              <a:t>150</a:t>
             </a:r>
             <a:endParaRPr lang="en-US" sz="1100" dirty="0"/>
           </a:p>

</xml_diff>

<commit_message>
docs(slide): refresh migration figures and count daily tests as features
Transportation converted 46 -> 108 (2 blocked, 106 running), Shell blocked
27 -> 25, taking the overall to 672/712 (94%). Sprint 16 is appended to the
trend rather than overwriting sprint 15, so the history stays intact.

The domain breakdown showed either a grey backlog or an amber blocked count,
never both, so Transportation could not report its 2 blocked tests alongside
its 40-test backlog. Build the number row per segment instead of either/or.

Composition was stale (635) and mixed units: three domains were feature
counts, Shell was a scenario count, and Transportation had not been updated
since it had 3 suites. Recount all four as .feature files in the nightly
manifest paths -> 693 daily. Cucumber reports 728 pickles for the same paths
because a few Scenario Outlines expand; the comment records both so the unit
is unambiguous next time.

Co-Authored-By: Claude Opus 5 (1M context) <noreply@anthropic.com>
</commit_message>
<xml_diff>
--- a/docs/Test-Migration-Progress.pptx
+++ b/docs/Test-Migration-Progress.pptx
@@ -188,9 +188,9 @@
           </c:marker>
           <c:cat>
             <c:multiLvlStrRef>
-              <c:f>Sheet1!$A$2:$A$8</c:f>
+              <c:f>Sheet1!$A$2:$A$9</c:f>
               <c:multiLvlStrCache>
-                <c:ptCount val="7"/>
+                <c:ptCount val="8"/>
                 <c:lvl>
                   <c:pt idx="0">
                     <c:v>9</c:v>
@@ -213,16 +213,19 @@
                   <c:pt idx="6">
                     <c:v>15</c:v>
                   </c:pt>
+                  <c:pt idx="7">
+                    <c:v>16</c:v>
+                  </c:pt>
                 </c:lvl>
               </c:multiLvlStrCache>
             </c:multiLvlStrRef>
           </c:cat>
           <c:val>
             <c:numRef>
-              <c:f>Sheet1!$B$2:$B$8</c:f>
+              <c:f>Sheet1!$B$2:$B$9</c:f>
               <c:numCache>
                 <c:formatCode>General</c:formatCode>
-                <c:ptCount val="7"/>
+                <c:ptCount val="8"/>
                 <c:pt idx="0">
                   <c:v>45</c:v>
                 </c:pt>
@@ -243,6 +246,9 @@
                 </c:pt>
                 <c:pt idx="6">
                   <c:v>86</c:v>
+                </c:pt>
+                <c:pt idx="7">
+                  <c:v>94</c:v>
                 </c:pt>
               </c:numCache>
             </c:numRef>
@@ -1625,7 +1631,7 @@
                 <a:ea typeface="Calibri" pitchFamily="34" charset="-122"/>
                 <a:cs typeface="Calibri" pitchFamily="34" charset="-120"/>
               </a:rPr>
-              <a:t>86%</a:t>
+              <a:t>94%</a:t>
             </a:r>
             <a:endParaRPr lang="en-US" sz="6400" dirty="0"/>
           </a:p>
@@ -1664,7 +1670,7 @@
                 <a:ea typeface="Calibri" pitchFamily="34" charset="-122"/>
                 <a:cs typeface="Calibri" pitchFamily="34" charset="-120"/>
               </a:rPr>
-              <a:t>610 / 712 tests migrated</a:t>
+              <a:t>672 / 712 tests migrated</a:t>
             </a:r>
             <a:endParaRPr lang="en-US" sz="1300" dirty="0"/>
           </a:p>
@@ -2263,7 +2269,7 @@
                 <a:ea typeface="Calibri" pitchFamily="34" charset="-122"/>
                 <a:cs typeface="Calibri" pitchFamily="34" charset="-120"/>
               </a:rPr>
-              <a:t>46</a:t>
+              <a:t>106</a:t>
             </a:r>
             <a:pPr indent="0" marL="0">
               <a:buNone/>
@@ -2291,7 +2297,35 @@
                 <a:ea typeface="Calibri" pitchFamily="34" charset="-122"/>
                 <a:cs typeface="Calibri" pitchFamily="34" charset="-120"/>
               </a:rPr>
-              <a:t>102</a:t>
+              <a:t>40</a:t>
+            </a:r>
+            <a:pPr indent="0" marL="0">
+              <a:buNone/>
+            </a:pPr>
+            <a:r>
+              <a:rPr lang="en-US" sz="1000" dirty="0">
+                <a:solidFill>
+                  <a:srgbClr val="6B7280"/>
+                </a:solidFill>
+                <a:latin typeface="Calibri" pitchFamily="34" charset="0"/>
+                <a:ea typeface="Calibri" pitchFamily="34" charset="-122"/>
+                <a:cs typeface="Calibri" pitchFamily="34" charset="-120"/>
+              </a:rPr>
+              <a:t>  </a:t>
+            </a:r>
+            <a:pPr indent="0" marL="0">
+              <a:buNone/>
+            </a:pPr>
+            <a:r>
+              <a:rPr lang="en-US" sz="1000" b="1" dirty="0">
+                <a:solidFill>
+                  <a:srgbClr val="F59E0B"/>
+                </a:solidFill>
+                <a:latin typeface="Calibri" pitchFamily="34" charset="0"/>
+                <a:ea typeface="Calibri" pitchFamily="34" charset="-122"/>
+                <a:cs typeface="Calibri" pitchFamily="34" charset="-120"/>
+              </a:rPr>
+              <a:t>2</a:t>
             </a:r>
             <a:endParaRPr lang="en-US" sz="1000" dirty="0"/>
           </a:p>
@@ -2330,7 +2364,7 @@
                 <a:ea typeface="Calibri" pitchFamily="34" charset="-122"/>
                 <a:cs typeface="Calibri" pitchFamily="34" charset="-120"/>
               </a:rPr>
-              <a:t>31%</a:t>
+              <a:t>73%</a:t>
             </a:r>
             <a:endParaRPr lang="en-US" sz="1100" dirty="0"/>
           </a:p>
@@ -2372,7 +2406,7 @@
         <p:spPr>
           <a:xfrm>
             <a:off x="4434840" y="4398264"/>
-            <a:ext cx="1051560" cy="182880"/>
+            <a:ext cx="2423160" cy="182880"/>
           </a:xfrm>
           <a:prstGeom prst="roundRect">
             <a:avLst>
@@ -2392,7 +2426,34 @@
       </p:sp>
       <p:sp>
         <p:nvSpPr>
-          <p:cNvPr id="29" name="Text 26"/>
+          <p:cNvPr id="29" name="Shape 26"/>
+          <p:cNvSpPr/>
+          <p:nvPr/>
+        </p:nvSpPr>
+        <p:spPr>
+          <a:xfrm>
+            <a:off x="6858000" y="4398264"/>
+            <a:ext cx="45720" cy="182880"/>
+          </a:xfrm>
+          <a:prstGeom prst="roundRect">
+            <a:avLst>
+              <a:gd name="adj" fmla="val 100000"/>
+            </a:avLst>
+          </a:prstGeom>
+          <a:solidFill>
+            <a:srgbClr val="F59E0B"/>
+          </a:solidFill>
+          <a:ln w="12700">
+            <a:solidFill>
+              <a:srgbClr val="F59E0B"/>
+            </a:solidFill>
+            <a:prstDash val="solid"/>
+          </a:ln>
+        </p:spPr>
+      </p:sp>
+      <p:sp>
+        <p:nvSpPr>
+          <p:cNvPr id="30" name="Text 27"/>
           <p:cNvSpPr/>
           <p:nvPr/>
         </p:nvSpPr>
@@ -2431,7 +2492,7 @@
       </p:sp>
       <p:sp>
         <p:nvSpPr>
-          <p:cNvPr id="30" name="Text 27"/>
+          <p:cNvPr id="31" name="Text 28"/>
           <p:cNvSpPr/>
           <p:nvPr/>
         </p:nvSpPr>
@@ -2490,7 +2551,7 @@
                 <a:ea typeface="Calibri" pitchFamily="34" charset="-122"/>
                 <a:cs typeface="Calibri" pitchFamily="34" charset="-120"/>
               </a:rPr>
-              <a:t>162</a:t>
+              <a:t>164</a:t>
             </a:r>
             <a:pPr indent="0" marL="0">
               <a:buNone/>
@@ -2518,7 +2579,7 @@
                 <a:ea typeface="Calibri" pitchFamily="34" charset="-122"/>
                 <a:cs typeface="Calibri" pitchFamily="34" charset="-120"/>
               </a:rPr>
-              <a:t>27</a:t>
+              <a:t>25</a:t>
             </a:r>
             <a:endParaRPr lang="en-US" sz="1000" dirty="0"/>
           </a:p>
@@ -2526,7 +2587,7 @@
       </p:sp>
       <p:sp>
         <p:nvSpPr>
-          <p:cNvPr id="31" name="Text 28"/>
+          <p:cNvPr id="32" name="Text 29"/>
           <p:cNvSpPr/>
           <p:nvPr/>
         </p:nvSpPr>
@@ -2565,14 +2626,14 @@
       </p:sp>
       <p:sp>
         <p:nvSpPr>
-          <p:cNvPr id="32" name="Shape 29"/>
+          <p:cNvPr id="33" name="Shape 30"/>
           <p:cNvSpPr/>
           <p:nvPr/>
         </p:nvSpPr>
         <p:spPr>
           <a:xfrm>
             <a:off x="4434840" y="4873752"/>
-            <a:ext cx="2899954" cy="182880"/>
+            <a:ext cx="2935756" cy="182880"/>
           </a:xfrm>
           <a:prstGeom prst="roundRect">
             <a:avLst>
@@ -2592,14 +2653,14 @@
       </p:sp>
       <p:sp>
         <p:nvSpPr>
-          <p:cNvPr id="33" name="Shape 30"/>
-          <p:cNvSpPr/>
-          <p:nvPr/>
-        </p:nvSpPr>
-        <p:spPr>
-          <a:xfrm>
-            <a:off x="7334794" y="4873752"/>
-            <a:ext cx="483326" cy="182880"/>
+          <p:cNvPr id="34" name="Shape 31"/>
+          <p:cNvSpPr/>
+          <p:nvPr/>
+        </p:nvSpPr>
+        <p:spPr>
+          <a:xfrm>
+            <a:off x="7370596" y="4873752"/>
+            <a:ext cx="447524" cy="182880"/>
           </a:xfrm>
           <a:prstGeom prst="roundRect">
             <a:avLst>
@@ -2619,7 +2680,7 @@
       </p:sp>
       <p:sp>
         <p:nvSpPr>
-          <p:cNvPr id="34" name="Text 31"/>
+          <p:cNvPr id="35" name="Text 32"/>
           <p:cNvSpPr/>
           <p:nvPr/>
         </p:nvSpPr>
@@ -2658,7 +2719,7 @@
       </p:sp>
       <p:sp>
         <p:nvSpPr>
-          <p:cNvPr id="35" name="Shape 32"/>
+          <p:cNvPr id="36" name="Shape 33"/>
           <p:cNvSpPr/>
           <p:nvPr/>
         </p:nvSpPr>
@@ -2683,7 +2744,7 @@
       </p:sp>
       <p:sp>
         <p:nvSpPr>
-          <p:cNvPr id="36" name="Text 33"/>
+          <p:cNvPr id="37" name="Text 34"/>
           <p:cNvSpPr/>
           <p:nvPr/>
         </p:nvSpPr>
@@ -2722,7 +2783,7 @@
       </p:sp>
       <p:sp>
         <p:nvSpPr>
-          <p:cNvPr id="37" name="Shape 34"/>
+          <p:cNvPr id="38" name="Shape 35"/>
           <p:cNvSpPr/>
           <p:nvPr/>
         </p:nvSpPr>
@@ -2747,7 +2808,7 @@
       </p:sp>
       <p:sp>
         <p:nvSpPr>
-          <p:cNvPr id="38" name="Text 35"/>
+          <p:cNvPr id="39" name="Text 36"/>
           <p:cNvSpPr/>
           <p:nvPr/>
         </p:nvSpPr>
@@ -2786,7 +2847,7 @@
       </p:sp>
       <p:sp>
         <p:nvSpPr>
-          <p:cNvPr id="39" name="Shape 36"/>
+          <p:cNvPr id="40" name="Shape 37"/>
           <p:cNvSpPr/>
           <p:nvPr/>
         </p:nvSpPr>
@@ -2811,7 +2872,7 @@
       </p:sp>
       <p:sp>
         <p:nvSpPr>
-          <p:cNvPr id="40" name="Text 37"/>
+          <p:cNvPr id="41" name="Text 38"/>
           <p:cNvSpPr/>
           <p:nvPr/>
         </p:nvSpPr>
@@ -2850,7 +2911,7 @@
       </p:sp>
       <p:sp>
         <p:nvSpPr>
-          <p:cNvPr id="41" name="Shape 38"/>
+          <p:cNvPr id="42" name="Shape 39"/>
           <p:cNvSpPr/>
           <p:nvPr/>
         </p:nvSpPr>
@@ -2877,7 +2938,7 @@
       </p:sp>
       <p:sp>
         <p:nvSpPr>
-          <p:cNvPr id="42" name="Text 39"/>
+          <p:cNvPr id="43" name="Text 40"/>
           <p:cNvSpPr/>
           <p:nvPr/>
         </p:nvSpPr>
@@ -2916,7 +2977,7 @@
       </p:sp>
       <p:sp>
         <p:nvSpPr>
-          <p:cNvPr id="43" name="Text 40"/>
+          <p:cNvPr id="44" name="Text 41"/>
           <p:cNvSpPr/>
           <p:nvPr/>
         </p:nvSpPr>
@@ -2955,7 +3016,7 @@
       </p:sp>
       <p:sp>
         <p:nvSpPr>
-          <p:cNvPr id="44" name="Shape 41"/>
+          <p:cNvPr id="45" name="Shape 42"/>
           <p:cNvSpPr/>
           <p:nvPr/>
         </p:nvSpPr>
@@ -2982,7 +3043,7 @@
       </p:sp>
       <p:sp>
         <p:nvSpPr>
-          <p:cNvPr id="45" name="Text 42"/>
+          <p:cNvPr id="46" name="Text 43"/>
           <p:cNvSpPr/>
           <p:nvPr/>
         </p:nvSpPr>
@@ -3013,7 +3074,7 @@
                 <a:ea typeface="Calibri" pitchFamily="34" charset="-122"/>
                 <a:cs typeface="Calibri" pitchFamily="34" charset="-120"/>
               </a:rPr>
-              <a:t>635</a:t>
+              <a:t>693</a:t>
             </a:r>
             <a:endParaRPr lang="en-US" sz="2200" dirty="0"/>
           </a:p>
@@ -3021,7 +3082,7 @@
       </p:sp>
       <p:sp>
         <p:nvSpPr>
-          <p:cNvPr id="46" name="Text 43"/>
+          <p:cNvPr id="47" name="Text 44"/>
           <p:cNvSpPr/>
           <p:nvPr/>
         </p:nvSpPr>
@@ -3060,7 +3121,7 @@
       </p:sp>
       <p:sp>
         <p:nvSpPr>
-          <p:cNvPr id="47" name="Shape 44"/>
+          <p:cNvPr id="48" name="Shape 45"/>
           <p:cNvSpPr/>
           <p:nvPr/>
         </p:nvSpPr>
@@ -3087,7 +3148,7 @@
       </p:sp>
       <p:sp>
         <p:nvSpPr>
-          <p:cNvPr id="48" name="Text 45"/>
+          <p:cNvPr id="49" name="Text 46"/>
           <p:cNvSpPr/>
           <p:nvPr/>
         </p:nvSpPr>
@@ -3126,7 +3187,7 @@
       </p:sp>
       <p:sp>
         <p:nvSpPr>
-          <p:cNvPr id="49" name="Text 46"/>
+          <p:cNvPr id="50" name="Text 47"/>
           <p:cNvSpPr/>
           <p:nvPr/>
         </p:nvSpPr>
@@ -3165,7 +3226,7 @@
       </p:sp>
       <p:sp>
         <p:nvSpPr>
-          <p:cNvPr id="50" name="Shape 47"/>
+          <p:cNvPr id="51" name="Shape 48"/>
           <p:cNvSpPr/>
           <p:nvPr/>
         </p:nvSpPr>
@@ -3192,7 +3253,7 @@
       </p:sp>
       <p:sp>
         <p:nvSpPr>
-          <p:cNvPr id="51" name="Text 48"/>
+          <p:cNvPr id="52" name="Text 49"/>
           <p:cNvSpPr/>
           <p:nvPr/>
         </p:nvSpPr>
@@ -3231,7 +3292,7 @@
       </p:sp>
       <p:sp>
         <p:nvSpPr>
-          <p:cNvPr id="52" name="Text 49"/>
+          <p:cNvPr id="53" name="Text 50"/>
           <p:cNvSpPr/>
           <p:nvPr/>
         </p:nvSpPr>
@@ -3270,7 +3331,7 @@
       </p:sp>
       <p:sp>
         <p:nvSpPr>
-          <p:cNvPr id="53" name="Text 50"/>
+          <p:cNvPr id="54" name="Text 51"/>
           <p:cNvSpPr/>
           <p:nvPr/>
         </p:nvSpPr>
@@ -3323,7 +3384,7 @@
       </p:sp>
       <p:sp>
         <p:nvSpPr>
-          <p:cNvPr id="54" name="Text 51"/>
+          <p:cNvPr id="55" name="Text 52"/>
           <p:cNvSpPr/>
           <p:nvPr/>
         </p:nvSpPr>
@@ -3362,7 +3423,7 @@
       </p:sp>
       <p:sp>
         <p:nvSpPr>
-          <p:cNvPr id="55" name="Text 52"/>
+          <p:cNvPr id="56" name="Text 53"/>
           <p:cNvSpPr/>
           <p:nvPr/>
         </p:nvSpPr>
@@ -3401,7 +3462,7 @@
       </p:sp>
       <p:sp>
         <p:nvSpPr>
-          <p:cNvPr id="56" name="Shape 53"/>
+          <p:cNvPr id="57" name="Shape 54"/>
           <p:cNvSpPr/>
           <p:nvPr/>
         </p:nvSpPr>
@@ -3428,14 +3489,14 @@
       </p:sp>
       <p:sp>
         <p:nvSpPr>
-          <p:cNvPr id="57" name="Shape 54"/>
+          <p:cNvPr id="58" name="Shape 55"/>
           <p:cNvSpPr/>
           <p:nvPr/>
         </p:nvSpPr>
         <p:spPr>
           <a:xfrm>
             <a:off x="9098280" y="5257800"/>
-            <a:ext cx="868032" cy="164592"/>
+            <a:ext cx="824411" cy="164592"/>
           </a:xfrm>
           <a:prstGeom prst="roundRect">
             <a:avLst>
@@ -3455,7 +3516,7 @@
       </p:sp>
       <p:sp>
         <p:nvSpPr>
-          <p:cNvPr id="58" name="Text 55"/>
+          <p:cNvPr id="59" name="Text 56"/>
           <p:cNvSpPr/>
           <p:nvPr/>
         </p:nvSpPr>
@@ -3486,7 +3547,7 @@
                 <a:ea typeface="Calibri" pitchFamily="34" charset="-122"/>
                 <a:cs typeface="Calibri" pitchFamily="34" charset="-120"/>
               </a:rPr>
-              <a:t>274</a:t>
+              <a:t>284</a:t>
             </a:r>
             <a:endParaRPr lang="en-US" sz="1100" dirty="0"/>
           </a:p>
@@ -3494,7 +3555,7 @@
       </p:sp>
       <p:sp>
         <p:nvSpPr>
-          <p:cNvPr id="59" name="Text 56"/>
+          <p:cNvPr id="60" name="Text 57"/>
           <p:cNvSpPr/>
           <p:nvPr/>
         </p:nvSpPr>
@@ -3533,7 +3594,7 @@
       </p:sp>
       <p:sp>
         <p:nvSpPr>
-          <p:cNvPr id="60" name="Shape 57"/>
+          <p:cNvPr id="61" name="Shape 58"/>
           <p:cNvSpPr/>
           <p:nvPr/>
         </p:nvSpPr>
@@ -3560,14 +3621,14 @@
       </p:sp>
       <p:sp>
         <p:nvSpPr>
-          <p:cNvPr id="61" name="Shape 58"/>
+          <p:cNvPr id="62" name="Shape 59"/>
           <p:cNvSpPr/>
           <p:nvPr/>
         </p:nvSpPr>
         <p:spPr>
           <a:xfrm>
             <a:off x="9098280" y="5559552"/>
-            <a:ext cx="354816" cy="164592"/>
+            <a:ext cx="333829" cy="164592"/>
           </a:xfrm>
           <a:prstGeom prst="roundRect">
             <a:avLst>
@@ -3587,7 +3648,7 @@
       </p:sp>
       <p:sp>
         <p:nvSpPr>
-          <p:cNvPr id="62" name="Text 59"/>
+          <p:cNvPr id="63" name="Text 60"/>
           <p:cNvSpPr/>
           <p:nvPr/>
         </p:nvSpPr>
@@ -3618,7 +3679,7 @@
                 <a:ea typeface="Calibri" pitchFamily="34" charset="-122"/>
                 <a:cs typeface="Calibri" pitchFamily="34" charset="-120"/>
               </a:rPr>
-              <a:t>112</a:t>
+              <a:t>115</a:t>
             </a:r>
             <a:endParaRPr lang="en-US" sz="1100" dirty="0"/>
           </a:p>
@@ -3626,7 +3687,7 @@
       </p:sp>
       <p:sp>
         <p:nvSpPr>
-          <p:cNvPr id="63" name="Text 60"/>
+          <p:cNvPr id="64" name="Text 61"/>
           <p:cNvSpPr/>
           <p:nvPr/>
         </p:nvSpPr>
@@ -3665,7 +3726,7 @@
       </p:sp>
       <p:sp>
         <p:nvSpPr>
-          <p:cNvPr id="64" name="Shape 61"/>
+          <p:cNvPr id="65" name="Shape 62"/>
           <p:cNvSpPr/>
           <p:nvPr/>
         </p:nvSpPr>
@@ -3692,14 +3753,14 @@
       </p:sp>
       <p:sp>
         <p:nvSpPr>
-          <p:cNvPr id="65" name="Shape 62"/>
+          <p:cNvPr id="66" name="Shape 63"/>
           <p:cNvSpPr/>
           <p:nvPr/>
         </p:nvSpPr>
         <p:spPr>
           <a:xfrm>
             <a:off x="9098280" y="5861304"/>
-            <a:ext cx="180576" cy="164592"/>
+            <a:ext cx="298994" cy="164592"/>
           </a:xfrm>
           <a:prstGeom prst="roundRect">
             <a:avLst>
@@ -3719,7 +3780,7 @@
       </p:sp>
       <p:sp>
         <p:nvSpPr>
-          <p:cNvPr id="66" name="Text 63"/>
+          <p:cNvPr id="67" name="Text 64"/>
           <p:cNvSpPr/>
           <p:nvPr/>
         </p:nvSpPr>
@@ -3750,7 +3811,7 @@
                 <a:ea typeface="Calibri" pitchFamily="34" charset="-122"/>
                 <a:cs typeface="Calibri" pitchFamily="34" charset="-120"/>
               </a:rPr>
-              <a:t>57</a:t>
+              <a:t>103</a:t>
             </a:r>
             <a:endParaRPr lang="en-US" sz="1100" dirty="0"/>
           </a:p>
@@ -3758,7 +3819,7 @@
       </p:sp>
       <p:sp>
         <p:nvSpPr>
-          <p:cNvPr id="67" name="Text 64"/>
+          <p:cNvPr id="68" name="Text 65"/>
           <p:cNvSpPr/>
           <p:nvPr/>
         </p:nvSpPr>
@@ -3797,7 +3858,7 @@
       </p:sp>
       <p:sp>
         <p:nvSpPr>
-          <p:cNvPr id="68" name="Shape 65"/>
+          <p:cNvPr id="69" name="Shape 66"/>
           <p:cNvSpPr/>
           <p:nvPr/>
         </p:nvSpPr>
@@ -3824,14 +3885,14 @@
       </p:sp>
       <p:sp>
         <p:nvSpPr>
-          <p:cNvPr id="69" name="Shape 66"/>
+          <p:cNvPr id="70" name="Shape 67"/>
           <p:cNvSpPr/>
           <p:nvPr/>
         </p:nvSpPr>
         <p:spPr>
           <a:xfrm>
             <a:off x="9098280" y="6163056"/>
-            <a:ext cx="608256" cy="164592"/>
+            <a:ext cx="554446" cy="164592"/>
           </a:xfrm>
           <a:prstGeom prst="roundRect">
             <a:avLst>
@@ -3851,7 +3912,7 @@
       </p:sp>
       <p:sp>
         <p:nvSpPr>
-          <p:cNvPr id="70" name="Text 67"/>
+          <p:cNvPr id="71" name="Text 68"/>
           <p:cNvSpPr/>
           <p:nvPr/>
         </p:nvSpPr>
@@ -3882,7 +3943,7 @@
                 <a:ea typeface="Calibri" pitchFamily="34" charset="-122"/>
                 <a:cs typeface="Calibri" pitchFamily="34" charset="-120"/>
               </a:rPr>
-              <a:t>192</a:t>
+              <a:t>191</a:t>
             </a:r>
             <a:endParaRPr lang="en-US" sz="1100" dirty="0"/>
           </a:p>
@@ -3890,7 +3951,7 @@
       </p:sp>
       <p:sp>
         <p:nvSpPr>
-          <p:cNvPr id="71" name="Text 68"/>
+          <p:cNvPr id="72" name="Text 69"/>
           <p:cNvSpPr/>
           <p:nvPr/>
         </p:nvSpPr>

</xml_diff>

<commit_message>
docs(slide): count evolvi_converted in the daily transportation total
cea5bbfc added rails/evolvi/evolvi_converted/ (8 features) to the nightly
transportation suite, so the daily figure moves 693 -> 701 across 60 suites.
Pickle count in the comment re-derived from a dry-run of the new manifest:
transportation 114 -> 122, total 728 -> 736.

Co-Authored-By: Claude Opus 5 (1M context) <noreply@anthropic.com>
</commit_message>
<xml_diff>
--- a/docs/Test-Migration-Progress.pptx
+++ b/docs/Test-Migration-Progress.pptx
@@ -3074,7 +3074,7 @@
                 <a:ea typeface="Calibri" pitchFamily="34" charset="-122"/>
                 <a:cs typeface="Calibri" pitchFamily="34" charset="-120"/>
               </a:rPr>
-              <a:t>693</a:t>
+              <a:t>701</a:t>
             </a:r>
             <a:endParaRPr lang="en-US" sz="2200" dirty="0"/>
           </a:p>
@@ -3496,7 +3496,7 @@
         <p:spPr>
           <a:xfrm>
             <a:off x="9098280" y="5257800"/>
-            <a:ext cx="824411" cy="164592"/>
+            <a:ext cx="815003" cy="164592"/>
           </a:xfrm>
           <a:prstGeom prst="roundRect">
             <a:avLst>
@@ -3628,7 +3628,7 @@
         <p:spPr>
           <a:xfrm>
             <a:off x="9098280" y="5559552"/>
-            <a:ext cx="333829" cy="164592"/>
+            <a:ext cx="330019" cy="164592"/>
           </a:xfrm>
           <a:prstGeom prst="roundRect">
             <a:avLst>
@@ -3760,7 +3760,7 @@
         <p:spPr>
           <a:xfrm>
             <a:off x="9098280" y="5861304"/>
-            <a:ext cx="298994" cy="164592"/>
+            <a:ext cx="318540" cy="164592"/>
           </a:xfrm>
           <a:prstGeom prst="roundRect">
             <a:avLst>
@@ -3811,7 +3811,7 @@
                 <a:ea typeface="Calibri" pitchFamily="34" charset="-122"/>
                 <a:cs typeface="Calibri" pitchFamily="34" charset="-120"/>
               </a:rPr>
-              <a:t>103</a:t>
+              <a:t>111</a:t>
             </a:r>
             <a:endParaRPr lang="en-US" sz="1100" dirty="0"/>
           </a:p>
@@ -3892,7 +3892,7 @@
         <p:spPr>
           <a:xfrm>
             <a:off x="9098280" y="6163056"/>
-            <a:ext cx="554446" cy="164592"/>
+            <a:ext cx="548118" cy="164592"/>
           </a:xfrm>
           <a:prstGeom prst="roundRect">
             <a:avLst>

</xml_diff>

<commit_message>
docs(slide): include the Sabre CD test in the daily transportation total
PR #238 added a feature under cars/sabre/, which is a nightly manifest path,
so transportation is 112 features and the daily figure 702. Pickle count in
the comment re-derived: transportation 123, total 737.

Co-Authored-By: Claude Opus 5 (1M context) <noreply@anthropic.com>
</commit_message>
<xml_diff>
--- a/docs/Test-Migration-Progress.pptx
+++ b/docs/Test-Migration-Progress.pptx
@@ -3074,7 +3074,7 @@
                 <a:ea typeface="Calibri" pitchFamily="34" charset="-122"/>
                 <a:cs typeface="Calibri" pitchFamily="34" charset="-120"/>
               </a:rPr>
-              <a:t>701</a:t>
+              <a:t>702</a:t>
             </a:r>
             <a:endParaRPr lang="en-US" sz="2200" dirty="0"/>
           </a:p>
@@ -3496,7 +3496,7 @@
         <p:spPr>
           <a:xfrm>
             <a:off x="9098280" y="5257800"/>
-            <a:ext cx="815003" cy="164592"/>
+            <a:ext cx="813842" cy="164592"/>
           </a:xfrm>
           <a:prstGeom prst="roundRect">
             <a:avLst>
@@ -3628,7 +3628,7 @@
         <p:spPr>
           <a:xfrm>
             <a:off x="9098280" y="5559552"/>
-            <a:ext cx="330019" cy="164592"/>
+            <a:ext cx="329549" cy="164592"/>
           </a:xfrm>
           <a:prstGeom prst="roundRect">
             <a:avLst>
@@ -3760,7 +3760,7 @@
         <p:spPr>
           <a:xfrm>
             <a:off x="9098280" y="5861304"/>
-            <a:ext cx="318540" cy="164592"/>
+            <a:ext cx="320952" cy="164592"/>
           </a:xfrm>
           <a:prstGeom prst="roundRect">
             <a:avLst>
@@ -3811,7 +3811,7 @@
                 <a:ea typeface="Calibri" pitchFamily="34" charset="-122"/>
                 <a:cs typeface="Calibri" pitchFamily="34" charset="-120"/>
               </a:rPr>
-              <a:t>111</a:t>
+              <a:t>112</a:t>
             </a:r>
             <a:endParaRPr lang="en-US" sz="1100" dirty="0"/>
           </a:p>
@@ -3892,7 +3892,7 @@
         <p:spPr>
           <a:xfrm>
             <a:off x="9098280" y="6163056"/>
-            <a:ext cx="548118" cy="164592"/>
+            <a:ext cx="547337" cy="164592"/>
           </a:xfrm>
           <a:prstGeom prst="roundRect">
             <a:avLst>

</xml_diff>